<commit_message>
Corrige plano románico y añade contexto histórico a cada estilo
- El ábside central de la iglesia de San Martín ahora se dibuja
  claramente más ancho que los dos laterales (proporción 1.6:1:1),
  como en el edificio real.
- Añade un breve párrafo de contexto histórico a cada uno de los 4
  estilos (románico, gótico, árabe, moderno), además de los datos del
  monumento concreto.
- Corrige pequeños solapamientos de etiquetas en los esquemas,
  verificados con una revisión visual independiente.

Co-Authored-By: Claude Sonnet 5 <noreply@anthropic.com>
Claude-Session: https://claude.ai/code/session_01SV4AB4NNKiXaeMuGEkh2i2
</commit_message>
<xml_diff>
--- a/docencia-espanol/materiales/b2/nuevo-espanol-en-marcha-4_unidad12b_lexico-arte.pptx
+++ b/docencia-espanol/materiales/b2/nuevo-espanol-en-marcha-4_unidad12b_lexico-arte.pptx
@@ -4858,8 +4858,8 @@
         </p:nvSpPr>
         <p:spPr>
           <a:xfrm>
-            <a:off x="868680" y="2741828"/>
-            <a:ext cx="1303934" cy="1338682"/>
+            <a:off x="868680" y="3104388"/>
+            <a:ext cx="1086612" cy="892454"/>
           </a:xfrm>
           <a:prstGeom prst="rect">
             <a:avLst/>
@@ -4883,8 +4883,8 @@
         </p:nvSpPr>
         <p:spPr>
           <a:xfrm>
-            <a:off x="2172614" y="2741828"/>
-            <a:ext cx="1303934" cy="1338682"/>
+            <a:off x="1955292" y="3104388"/>
+            <a:ext cx="1738579" cy="892454"/>
           </a:xfrm>
           <a:prstGeom prst="rect">
             <a:avLst/>
@@ -4908,8 +4908,8 @@
         </p:nvSpPr>
         <p:spPr>
           <a:xfrm>
-            <a:off x="3476549" y="2741828"/>
-            <a:ext cx="1303934" cy="1338682"/>
+            <a:off x="3693871" y="3104388"/>
+            <a:ext cx="1086612" cy="892454"/>
           </a:xfrm>
           <a:prstGeom prst="rect">
             <a:avLst/>
@@ -4933,8 +4933,8 @@
         </p:nvSpPr>
         <p:spPr>
           <a:xfrm>
-            <a:off x="164555" y="2741828"/>
-            <a:ext cx="5320052" cy="374831"/>
+            <a:off x="164555" y="3104388"/>
+            <a:ext cx="5320052" cy="249887"/>
           </a:xfrm>
           <a:prstGeom prst="rect">
             <a:avLst/>
@@ -4960,8 +4960,8 @@
         </p:nvSpPr>
         <p:spPr>
           <a:xfrm>
-            <a:off x="933877" y="2155058"/>
-            <a:ext cx="1173541" cy="1173541"/>
+            <a:off x="912144" y="2604546"/>
+            <a:ext cx="999683" cy="999683"/>
           </a:xfrm>
           <a:prstGeom prst="pie">
             <a:avLst>
@@ -4988,8 +4988,8 @@
         </p:nvSpPr>
         <p:spPr>
           <a:xfrm>
-            <a:off x="2237811" y="2155058"/>
-            <a:ext cx="1173541" cy="1173541"/>
+            <a:off x="2024835" y="2304642"/>
+            <a:ext cx="1599493" cy="1599493"/>
           </a:xfrm>
           <a:prstGeom prst="pie">
             <a:avLst>
@@ -5018,8 +5018,8 @@
         </p:nvSpPr>
         <p:spPr>
           <a:xfrm>
-            <a:off x="3541746" y="2155058"/>
-            <a:ext cx="1173541" cy="1173541"/>
+            <a:off x="3737336" y="2604546"/>
+            <a:ext cx="999683" cy="999683"/>
           </a:xfrm>
           <a:prstGeom prst="pie">
             <a:avLst>
@@ -5046,8 +5046,8 @@
         </p:nvSpPr>
         <p:spPr>
           <a:xfrm>
-            <a:off x="806091" y="3871880"/>
-            <a:ext cx="417259" cy="208630"/>
+            <a:off x="779035" y="3698024"/>
+            <a:ext cx="597637" cy="298818"/>
           </a:xfrm>
           <a:prstGeom prst="rect">
             <a:avLst/>
@@ -5066,8 +5066,8 @@
         </p:nvSpPr>
         <p:spPr>
           <a:xfrm>
-            <a:off x="4425813" y="3871880"/>
-            <a:ext cx="417259" cy="208630"/>
+            <a:off x="4272492" y="3698024"/>
+            <a:ext cx="597637" cy="298818"/>
           </a:xfrm>
           <a:prstGeom prst="rect">
             <a:avLst/>
@@ -5086,7 +5086,7 @@
         </p:nvSpPr>
         <p:spPr>
           <a:xfrm>
-            <a:off x="731520" y="1862450"/>
+            <a:off x="731520" y="2012034"/>
             <a:ext cx="4186123" cy="274320"/>
           </a:xfrm>
           <a:prstGeom prst="rect">
@@ -5111,7 +5111,7 @@
                 <a:ea typeface="Calibri" pitchFamily="34" charset="-122"/>
                 <a:cs typeface="Calibri" pitchFamily="34" charset="-120"/>
               </a:rPr>
-              <a:t>3 ábsides semicirculares</a:t>
+              <a:t>3 ábsides (el central, más ancho)</a:t>
             </a:r>
             <a:endParaRPr lang="en-US" sz="950" dirty="0"/>
           </a:p>
@@ -5125,7 +5125,7 @@
         </p:nvSpPr>
         <p:spPr>
           <a:xfrm>
-            <a:off x="4858719" y="2819516"/>
+            <a:off x="4858719" y="3119604"/>
             <a:ext cx="1463040" cy="274320"/>
           </a:xfrm>
           <a:prstGeom prst="rect">
@@ -5164,8 +5164,8 @@
         </p:nvSpPr>
         <p:spPr>
           <a:xfrm>
-            <a:off x="2172614" y="3277301"/>
-            <a:ext cx="1303934" cy="274320"/>
+            <a:off x="1955292" y="3461370"/>
+            <a:ext cx="1738579" cy="274320"/>
           </a:xfrm>
           <a:prstGeom prst="rect">
             <a:avLst/>
@@ -5203,8 +5203,8 @@
         </p:nvSpPr>
         <p:spPr>
           <a:xfrm>
-            <a:off x="822960" y="3277301"/>
-            <a:ext cx="1395374" cy="274320"/>
+            <a:off x="731520" y="3461370"/>
+            <a:ext cx="1360932" cy="274320"/>
           </a:xfrm>
           <a:prstGeom prst="rect">
             <a:avLst/>
@@ -5220,7 +5220,7 @@
               <a:buNone/>
             </a:pPr>
             <a:r>
-              <a:rPr lang="en-US" sz="750" dirty="0">
+              <a:rPr lang="en-US" sz="700" dirty="0">
                 <a:solidFill>
                   <a:srgbClr val="5C6690"/>
                 </a:solidFill>
@@ -5230,7 +5230,7 @@
               </a:rPr>
               <a:t>nave lateral</a:t>
             </a:r>
-            <a:endParaRPr lang="en-US" sz="750" dirty="0"/>
+            <a:endParaRPr lang="en-US" sz="700" dirty="0"/>
           </a:p>
         </p:txBody>
       </p:sp>
@@ -5242,7 +5242,7 @@
         </p:nvSpPr>
         <p:spPr>
           <a:xfrm>
-            <a:off x="594360" y="4153662"/>
+            <a:off x="594360" y="4069994"/>
             <a:ext cx="4460443" cy="274320"/>
           </a:xfrm>
           <a:prstGeom prst="rect">
@@ -5275,80 +5275,18 @@
       </p:sp>
       <p:sp>
         <p:nvSpPr>
-          <p:cNvPr id="20" name="Text 18"/>
+          <p:cNvPr id="20" name="Shape 18"/>
           <p:cNvSpPr/>
           <p:nvPr/>
         </p:nvSpPr>
         <p:spPr>
           <a:xfrm>
             <a:off x="548640" y="4928616"/>
-            <a:ext cx="6949440" cy="457200"/>
-          </a:xfrm>
-          <a:prstGeom prst="rect">
-            <a:avLst/>
-          </a:prstGeom>
-          <a:noFill/>
-          <a:ln/>
-        </p:spPr>
-        <p:txBody>
-          <a:bodyPr wrap="square" lIns="0" tIns="0" rIns="0" bIns="0" rtlCol="0" anchor="ctr"/>
-          <a:lstStyle/>
-          <a:p>
-            <a:pPr algn="ctr" indent="0" marL="0">
-              <a:lnSpc>
-                <a:spcPct val="110000"/>
-              </a:lnSpc>
-              <a:buNone/>
-            </a:pPr>
-            <a:r>
-              <a:rPr lang="en-US" sz="1150" i="1" dirty="0">
-                <a:solidFill>
-                  <a:srgbClr val="5C6690"/>
-                </a:solidFill>
-                <a:latin typeface="Calibri" pitchFamily="34" charset="0"/>
-                <a:ea typeface="Calibri" pitchFamily="34" charset="-122"/>
-                <a:cs typeface="Calibri" pitchFamily="34" charset="-120"/>
-              </a:rPr>
-              <a:t>Construida en el Camino de Santiago (Palencia). Planta de 3 naves + crucero,</a:t>
-            </a:r>
-            <a:endParaRPr lang="en-US" sz="1150" dirty="0"/>
-          </a:p>
-          <a:p>
-            <a:pPr algn="ctr" indent="0" marL="0">
-              <a:lnSpc>
-                <a:spcPct val="110000"/>
-              </a:lnSpc>
-              <a:buNone/>
-            </a:pPr>
-            <a:r>
-              <a:rPr lang="en-US" sz="1150" i="1" dirty="0">
-                <a:solidFill>
-                  <a:srgbClr val="5C6690"/>
-                </a:solidFill>
-                <a:latin typeface="Calibri" pitchFamily="34" charset="0"/>
-                <a:ea typeface="Calibri" pitchFamily="34" charset="-122"/>
-                <a:cs typeface="Calibri" pitchFamily="34" charset="-120"/>
-              </a:rPr>
-              <a:t>con 3 ábsides semicirculares en la cabecera y 2 torrecillas en la fachada.</a:t>
-            </a:r>
-            <a:endParaRPr lang="en-US" sz="1150" dirty="0"/>
-          </a:p>
-        </p:txBody>
-      </p:sp>
-      <p:sp>
-        <p:nvSpPr>
-          <p:cNvPr id="21" name="Shape 19"/>
-          <p:cNvSpPr/>
-          <p:nvPr/>
-        </p:nvSpPr>
-        <p:spPr>
-          <a:xfrm>
-            <a:off x="7772400" y="1572768"/>
-            <a:ext cx="3867912" cy="388620"/>
+            <a:ext cx="6949440" cy="960120"/>
           </a:xfrm>
           <a:prstGeom prst="roundRect">
             <a:avLst>
-              <a:gd name="adj" fmla="val 14118"/>
+              <a:gd name="adj" fmla="val 7619"/>
             </a:avLst>
           </a:prstGeom>
           <a:solidFill>
@@ -5359,14 +5297,78 @@
       </p:sp>
       <p:sp>
         <p:nvSpPr>
-          <p:cNvPr id="22" name="Text 20"/>
+          <p:cNvPr id="21" name="Text 19"/>
+          <p:cNvSpPr/>
+          <p:nvPr/>
+        </p:nvSpPr>
+        <p:spPr>
+          <a:xfrm>
+            <a:off x="749808" y="4928616"/>
+            <a:ext cx="6547104" cy="960120"/>
+          </a:xfrm>
+          <a:prstGeom prst="rect">
+            <a:avLst/>
+          </a:prstGeom>
+          <a:noFill/>
+          <a:ln/>
+        </p:spPr>
+        <p:txBody>
+          <a:bodyPr wrap="square" lIns="0" tIns="0" rIns="0" bIns="0" rtlCol="0" anchor="ctr"/>
+          <a:lstStyle/>
+          <a:p>
+            <a:pPr algn="l" indent="0" marL="0">
+              <a:lnSpc>
+                <a:spcPct val="112000"/>
+              </a:lnSpc>
+              <a:buNone/>
+            </a:pPr>
+            <a:r>
+              <a:rPr lang="en-US" sz="1050" dirty="0">
+                <a:solidFill>
+                  <a:srgbClr val="2F3C7E"/>
+                </a:solidFill>
+                <a:latin typeface="Calibri" pitchFamily="34" charset="0"/>
+                <a:ea typeface="Calibri" pitchFamily="34" charset="-122"/>
+                <a:cs typeface="Calibri" pitchFamily="34" charset="-120"/>
+              </a:rPr>
+              <a:t>El arte románico (s. XI-XII) fue el primer gran estilo internacional de la Europa cristiana medieval, ligado a monasterios y al Camino de Santiago. Esta iglesia se construyó en Frómista (Palencia): planta de 3 naves + crucero, con 3 ábsides semicirculares — el central, más ancho — y 2 torrecillas en la fachada.</a:t>
+            </a:r>
+            <a:endParaRPr lang="en-US" sz="1050" dirty="0"/>
+          </a:p>
+        </p:txBody>
+      </p:sp>
+      <p:sp>
+        <p:nvSpPr>
+          <p:cNvPr id="22" name="Shape 20"/>
+          <p:cNvSpPr/>
+          <p:nvPr/>
+        </p:nvSpPr>
+        <p:spPr>
+          <a:xfrm>
+            <a:off x="7772400" y="1572768"/>
+            <a:ext cx="3867912" cy="459486"/>
+          </a:xfrm>
+          <a:prstGeom prst="roundRect">
+            <a:avLst>
+              <a:gd name="adj" fmla="val 11940"/>
+            </a:avLst>
+          </a:prstGeom>
+          <a:solidFill>
+            <a:srgbClr val="F5F6FB"/>
+          </a:solidFill>
+          <a:ln/>
+        </p:spPr>
+      </p:sp>
+      <p:sp>
+        <p:nvSpPr>
+          <p:cNvPr id="23" name="Text 21"/>
           <p:cNvSpPr/>
           <p:nvPr/>
         </p:nvSpPr>
         <p:spPr>
           <a:xfrm>
             <a:off x="7845552" y="1572768"/>
-            <a:ext cx="297180" cy="388620"/>
+            <a:ext cx="329184" cy="459486"/>
           </a:xfrm>
           <a:prstGeom prst="rect">
             <a:avLst/>
@@ -5382,27 +5384,27 @@
               <a:buNone/>
             </a:pPr>
             <a:r>
-              <a:rPr lang="en-US" sz="1000" dirty="0">
+              <a:rPr lang="en-US" sz="1100" dirty="0">
                 <a:solidFill>
                   <a:srgbClr val="000000"/>
                 </a:solidFill>
               </a:rPr>
               <a:t>⛪</a:t>
             </a:r>
-            <a:endParaRPr lang="en-US" sz="1000" dirty="0"/>
-          </a:p>
-        </p:txBody>
-      </p:sp>
-      <p:sp>
-        <p:nvSpPr>
-          <p:cNvPr id="23" name="Text 21"/>
-          <p:cNvSpPr/>
-          <p:nvPr/>
-        </p:nvSpPr>
-        <p:spPr>
-          <a:xfrm>
-            <a:off x="8234172" y="1591056"/>
-            <a:ext cx="3296412" cy="352044"/>
+            <a:endParaRPr lang="en-US" sz="1100" dirty="0"/>
+          </a:p>
+        </p:txBody>
+      </p:sp>
+      <p:sp>
+        <p:nvSpPr>
+          <p:cNvPr id="24" name="Text 22"/>
+          <p:cNvSpPr/>
+          <p:nvPr/>
+        </p:nvSpPr>
+        <p:spPr>
+          <a:xfrm>
+            <a:off x="8266176" y="1591056"/>
+            <a:ext cx="3264408" cy="422910"/>
           </a:xfrm>
           <a:prstGeom prst="rect">
             <a:avLst/>
@@ -5457,18 +5459,18 @@
       </p:sp>
       <p:sp>
         <p:nvSpPr>
-          <p:cNvPr id="24" name="Shape 22"/>
-          <p:cNvSpPr/>
-          <p:nvPr/>
-        </p:nvSpPr>
-        <p:spPr>
-          <a:xfrm>
-            <a:off x="7772400" y="2052828"/>
-            <a:ext cx="3867912" cy="388620"/>
+          <p:cNvPr id="25" name="Shape 23"/>
+          <p:cNvSpPr/>
+          <p:nvPr/>
+        </p:nvSpPr>
+        <p:spPr>
+          <a:xfrm>
+            <a:off x="7772400" y="2123694"/>
+            <a:ext cx="3867912" cy="459486"/>
           </a:xfrm>
           <a:prstGeom prst="roundRect">
             <a:avLst>
-              <a:gd name="adj" fmla="val 14118"/>
+              <a:gd name="adj" fmla="val 11940"/>
             </a:avLst>
           </a:prstGeom>
           <a:solidFill>
@@ -5479,14 +5481,14 @@
       </p:sp>
       <p:sp>
         <p:nvSpPr>
-          <p:cNvPr id="25" name="Text 23"/>
-          <p:cNvSpPr/>
-          <p:nvPr/>
-        </p:nvSpPr>
-        <p:spPr>
-          <a:xfrm>
-            <a:off x="7845552" y="2052828"/>
-            <a:ext cx="297180" cy="388620"/>
+          <p:cNvPr id="26" name="Text 24"/>
+          <p:cNvSpPr/>
+          <p:nvPr/>
+        </p:nvSpPr>
+        <p:spPr>
+          <a:xfrm>
+            <a:off x="7845552" y="2123694"/>
+            <a:ext cx="329184" cy="459486"/>
           </a:xfrm>
           <a:prstGeom prst="rect">
             <a:avLst/>
@@ -5502,27 +5504,27 @@
               <a:buNone/>
             </a:pPr>
             <a:r>
-              <a:rPr lang="en-US" sz="1000" dirty="0">
+              <a:rPr lang="en-US" sz="1100" dirty="0">
                 <a:solidFill>
                   <a:srgbClr val="000000"/>
                 </a:solidFill>
               </a:rPr>
               <a:t>🌉</a:t>
             </a:r>
-            <a:endParaRPr lang="en-US" sz="1000" dirty="0"/>
-          </a:p>
-        </p:txBody>
-      </p:sp>
-      <p:sp>
-        <p:nvSpPr>
-          <p:cNvPr id="26" name="Text 24"/>
-          <p:cNvSpPr/>
-          <p:nvPr/>
-        </p:nvSpPr>
-        <p:spPr>
-          <a:xfrm>
-            <a:off x="8234172" y="2071116"/>
-            <a:ext cx="3296412" cy="352044"/>
+            <a:endParaRPr lang="en-US" sz="1100" dirty="0"/>
+          </a:p>
+        </p:txBody>
+      </p:sp>
+      <p:sp>
+        <p:nvSpPr>
+          <p:cNvPr id="27" name="Text 25"/>
+          <p:cNvSpPr/>
+          <p:nvPr/>
+        </p:nvSpPr>
+        <p:spPr>
+          <a:xfrm>
+            <a:off x="8266176" y="2141982"/>
+            <a:ext cx="3264408" cy="422910"/>
           </a:xfrm>
           <a:prstGeom prst="rect">
             <a:avLst/>
@@ -5577,18 +5579,18 @@
       </p:sp>
       <p:sp>
         <p:nvSpPr>
-          <p:cNvPr id="27" name="Shape 25"/>
-          <p:cNvSpPr/>
-          <p:nvPr/>
-        </p:nvSpPr>
-        <p:spPr>
-          <a:xfrm>
-            <a:off x="7772400" y="2532888"/>
-            <a:ext cx="3867912" cy="388620"/>
+          <p:cNvPr id="28" name="Shape 26"/>
+          <p:cNvSpPr/>
+          <p:nvPr/>
+        </p:nvSpPr>
+        <p:spPr>
+          <a:xfrm>
+            <a:off x="7772400" y="2674620"/>
+            <a:ext cx="3867912" cy="459486"/>
           </a:xfrm>
           <a:prstGeom prst="roundRect">
             <a:avLst>
-              <a:gd name="adj" fmla="val 14118"/>
+              <a:gd name="adj" fmla="val 11940"/>
             </a:avLst>
           </a:prstGeom>
           <a:solidFill>
@@ -5599,14 +5601,14 @@
       </p:sp>
       <p:sp>
         <p:nvSpPr>
-          <p:cNvPr id="28" name="Text 26"/>
-          <p:cNvSpPr/>
-          <p:nvPr/>
-        </p:nvSpPr>
-        <p:spPr>
-          <a:xfrm>
-            <a:off x="7845552" y="2532888"/>
-            <a:ext cx="297180" cy="388620"/>
+          <p:cNvPr id="29" name="Text 27"/>
+          <p:cNvSpPr/>
+          <p:nvPr/>
+        </p:nvSpPr>
+        <p:spPr>
+          <a:xfrm>
+            <a:off x="7845552" y="2674620"/>
+            <a:ext cx="329184" cy="459486"/>
           </a:xfrm>
           <a:prstGeom prst="rect">
             <a:avLst/>
@@ -5622,27 +5624,27 @@
               <a:buNone/>
             </a:pPr>
             <a:r>
-              <a:rPr lang="en-US" sz="1000" dirty="0">
+              <a:rPr lang="en-US" sz="1100" dirty="0">
                 <a:solidFill>
                   <a:srgbClr val="000000"/>
                 </a:solidFill>
               </a:rPr>
               <a:t>◗</a:t>
             </a:r>
-            <a:endParaRPr lang="en-US" sz="1000" dirty="0"/>
-          </a:p>
-        </p:txBody>
-      </p:sp>
-      <p:sp>
-        <p:nvSpPr>
-          <p:cNvPr id="29" name="Text 27"/>
-          <p:cNvSpPr/>
-          <p:nvPr/>
-        </p:nvSpPr>
-        <p:spPr>
-          <a:xfrm>
-            <a:off x="8234172" y="2551176"/>
-            <a:ext cx="3296412" cy="352044"/>
+            <a:endParaRPr lang="en-US" sz="1100" dirty="0"/>
+          </a:p>
+        </p:txBody>
+      </p:sp>
+      <p:sp>
+        <p:nvSpPr>
+          <p:cNvPr id="30" name="Text 28"/>
+          <p:cNvSpPr/>
+          <p:nvPr/>
+        </p:nvSpPr>
+        <p:spPr>
+          <a:xfrm>
+            <a:off x="8266176" y="2692908"/>
+            <a:ext cx="3264408" cy="422910"/>
           </a:xfrm>
           <a:prstGeom prst="rect">
             <a:avLst/>
@@ -5697,18 +5699,18 @@
       </p:sp>
       <p:sp>
         <p:nvSpPr>
-          <p:cNvPr id="30" name="Shape 28"/>
-          <p:cNvSpPr/>
-          <p:nvPr/>
-        </p:nvSpPr>
-        <p:spPr>
-          <a:xfrm>
-            <a:off x="7772400" y="3012948"/>
-            <a:ext cx="3867912" cy="388620"/>
+          <p:cNvPr id="31" name="Shape 29"/>
+          <p:cNvSpPr/>
+          <p:nvPr/>
+        </p:nvSpPr>
+        <p:spPr>
+          <a:xfrm>
+            <a:off x="7772400" y="3225546"/>
+            <a:ext cx="3867912" cy="459486"/>
           </a:xfrm>
           <a:prstGeom prst="roundRect">
             <a:avLst>
-              <a:gd name="adj" fmla="val 14118"/>
+              <a:gd name="adj" fmla="val 11940"/>
             </a:avLst>
           </a:prstGeom>
           <a:solidFill>
@@ -5719,14 +5721,14 @@
       </p:sp>
       <p:sp>
         <p:nvSpPr>
-          <p:cNvPr id="31" name="Text 29"/>
-          <p:cNvSpPr/>
-          <p:nvPr/>
-        </p:nvSpPr>
-        <p:spPr>
-          <a:xfrm>
-            <a:off x="7845552" y="3012948"/>
-            <a:ext cx="297180" cy="388620"/>
+          <p:cNvPr id="32" name="Text 30"/>
+          <p:cNvSpPr/>
+          <p:nvPr/>
+        </p:nvSpPr>
+        <p:spPr>
+          <a:xfrm>
+            <a:off x="7845552" y="3225546"/>
+            <a:ext cx="329184" cy="459486"/>
           </a:xfrm>
           <a:prstGeom prst="rect">
             <a:avLst/>
@@ -5742,27 +5744,27 @@
               <a:buNone/>
             </a:pPr>
             <a:r>
-              <a:rPr lang="en-US" sz="1000" dirty="0">
+              <a:rPr lang="en-US" sz="1100" dirty="0">
                 <a:solidFill>
                   <a:srgbClr val="000000"/>
                 </a:solidFill>
               </a:rPr>
               <a:t>🔵</a:t>
             </a:r>
-            <a:endParaRPr lang="en-US" sz="1000" dirty="0"/>
-          </a:p>
-        </p:txBody>
-      </p:sp>
-      <p:sp>
-        <p:nvSpPr>
-          <p:cNvPr id="32" name="Text 30"/>
-          <p:cNvSpPr/>
-          <p:nvPr/>
-        </p:nvSpPr>
-        <p:spPr>
-          <a:xfrm>
-            <a:off x="8234172" y="3031236"/>
-            <a:ext cx="3296412" cy="352044"/>
+            <a:endParaRPr lang="en-US" sz="1100" dirty="0"/>
+          </a:p>
+        </p:txBody>
+      </p:sp>
+      <p:sp>
+        <p:nvSpPr>
+          <p:cNvPr id="33" name="Text 31"/>
+          <p:cNvSpPr/>
+          <p:nvPr/>
+        </p:nvSpPr>
+        <p:spPr>
+          <a:xfrm>
+            <a:off x="8266176" y="3243834"/>
+            <a:ext cx="3264408" cy="422910"/>
           </a:xfrm>
           <a:prstGeom prst="rect">
             <a:avLst/>
@@ -5817,18 +5819,18 @@
       </p:sp>
       <p:sp>
         <p:nvSpPr>
-          <p:cNvPr id="33" name="Shape 31"/>
-          <p:cNvSpPr/>
-          <p:nvPr/>
-        </p:nvSpPr>
-        <p:spPr>
-          <a:xfrm>
-            <a:off x="7772400" y="3493008"/>
-            <a:ext cx="3867912" cy="388620"/>
+          <p:cNvPr id="34" name="Shape 32"/>
+          <p:cNvSpPr/>
+          <p:nvPr/>
+        </p:nvSpPr>
+        <p:spPr>
+          <a:xfrm>
+            <a:off x="7772400" y="3776472"/>
+            <a:ext cx="3867912" cy="459486"/>
           </a:xfrm>
           <a:prstGeom prst="roundRect">
             <a:avLst>
-              <a:gd name="adj" fmla="val 14118"/>
+              <a:gd name="adj" fmla="val 11940"/>
             </a:avLst>
           </a:prstGeom>
           <a:solidFill>
@@ -5839,14 +5841,14 @@
       </p:sp>
       <p:sp>
         <p:nvSpPr>
-          <p:cNvPr id="34" name="Text 32"/>
-          <p:cNvSpPr/>
-          <p:nvPr/>
-        </p:nvSpPr>
-        <p:spPr>
-          <a:xfrm>
-            <a:off x="7845552" y="3493008"/>
-            <a:ext cx="297180" cy="388620"/>
+          <p:cNvPr id="35" name="Text 33"/>
+          <p:cNvSpPr/>
+          <p:nvPr/>
+        </p:nvSpPr>
+        <p:spPr>
+          <a:xfrm>
+            <a:off x="7845552" y="3776472"/>
+            <a:ext cx="329184" cy="459486"/>
           </a:xfrm>
           <a:prstGeom prst="rect">
             <a:avLst/>
@@ -5862,27 +5864,27 @@
               <a:buNone/>
             </a:pPr>
             <a:r>
-              <a:rPr lang="en-US" sz="1000" dirty="0">
+              <a:rPr lang="en-US" sz="1100" dirty="0">
                 <a:solidFill>
                   <a:srgbClr val="000000"/>
                 </a:solidFill>
               </a:rPr>
               <a:t>➕</a:t>
             </a:r>
-            <a:endParaRPr lang="en-US" sz="1000" dirty="0"/>
-          </a:p>
-        </p:txBody>
-      </p:sp>
-      <p:sp>
-        <p:nvSpPr>
-          <p:cNvPr id="35" name="Text 33"/>
-          <p:cNvSpPr/>
-          <p:nvPr/>
-        </p:nvSpPr>
-        <p:spPr>
-          <a:xfrm>
-            <a:off x="8234172" y="3511296"/>
-            <a:ext cx="3296412" cy="352044"/>
+            <a:endParaRPr lang="en-US" sz="1100" dirty="0"/>
+          </a:p>
+        </p:txBody>
+      </p:sp>
+      <p:sp>
+        <p:nvSpPr>
+          <p:cNvPr id="36" name="Text 34"/>
+          <p:cNvSpPr/>
+          <p:nvPr/>
+        </p:nvSpPr>
+        <p:spPr>
+          <a:xfrm>
+            <a:off x="8266176" y="3794760"/>
+            <a:ext cx="3264408" cy="422910"/>
           </a:xfrm>
           <a:prstGeom prst="rect">
             <a:avLst/>
@@ -5937,18 +5939,18 @@
       </p:sp>
       <p:sp>
         <p:nvSpPr>
-          <p:cNvPr id="36" name="Shape 34"/>
-          <p:cNvSpPr/>
-          <p:nvPr/>
-        </p:nvSpPr>
-        <p:spPr>
-          <a:xfrm>
-            <a:off x="7772400" y="3973068"/>
-            <a:ext cx="3867912" cy="388620"/>
+          <p:cNvPr id="37" name="Shape 35"/>
+          <p:cNvSpPr/>
+          <p:nvPr/>
+        </p:nvSpPr>
+        <p:spPr>
+          <a:xfrm>
+            <a:off x="7772400" y="4327398"/>
+            <a:ext cx="3867912" cy="459486"/>
           </a:xfrm>
           <a:prstGeom prst="roundRect">
             <a:avLst>
-              <a:gd name="adj" fmla="val 14118"/>
+              <a:gd name="adj" fmla="val 11940"/>
             </a:avLst>
           </a:prstGeom>
           <a:solidFill>
@@ -5959,14 +5961,14 @@
       </p:sp>
       <p:sp>
         <p:nvSpPr>
-          <p:cNvPr id="37" name="Text 35"/>
-          <p:cNvSpPr/>
-          <p:nvPr/>
-        </p:nvSpPr>
-        <p:spPr>
-          <a:xfrm>
-            <a:off x="7845552" y="3973068"/>
-            <a:ext cx="297180" cy="388620"/>
+          <p:cNvPr id="38" name="Text 36"/>
+          <p:cNvSpPr/>
+          <p:nvPr/>
+        </p:nvSpPr>
+        <p:spPr>
+          <a:xfrm>
+            <a:off x="7845552" y="4327398"/>
+            <a:ext cx="329184" cy="459486"/>
           </a:xfrm>
           <a:prstGeom prst="rect">
             <a:avLst/>
@@ -5982,27 +5984,27 @@
               <a:buNone/>
             </a:pPr>
             <a:r>
-              <a:rPr lang="en-US" sz="1000" dirty="0">
+              <a:rPr lang="en-US" sz="1100" dirty="0">
                 <a:solidFill>
                   <a:srgbClr val="000000"/>
                 </a:solidFill>
               </a:rPr>
               <a:t>🗼</a:t>
             </a:r>
-            <a:endParaRPr lang="en-US" sz="1000" dirty="0"/>
-          </a:p>
-        </p:txBody>
-      </p:sp>
-      <p:sp>
-        <p:nvSpPr>
-          <p:cNvPr id="38" name="Text 36"/>
-          <p:cNvSpPr/>
-          <p:nvPr/>
-        </p:nvSpPr>
-        <p:spPr>
-          <a:xfrm>
-            <a:off x="8234172" y="3991356"/>
-            <a:ext cx="3296412" cy="352044"/>
+            <a:endParaRPr lang="en-US" sz="1100" dirty="0"/>
+          </a:p>
+        </p:txBody>
+      </p:sp>
+      <p:sp>
+        <p:nvSpPr>
+          <p:cNvPr id="39" name="Text 37"/>
+          <p:cNvSpPr/>
+          <p:nvPr/>
+        </p:nvSpPr>
+        <p:spPr>
+          <a:xfrm>
+            <a:off x="8266176" y="4345686"/>
+            <a:ext cx="3264408" cy="422910"/>
           </a:xfrm>
           <a:prstGeom prst="rect">
             <a:avLst/>
@@ -6057,18 +6059,18 @@
       </p:sp>
       <p:sp>
         <p:nvSpPr>
-          <p:cNvPr id="39" name="Shape 37"/>
-          <p:cNvSpPr/>
-          <p:nvPr/>
-        </p:nvSpPr>
-        <p:spPr>
-          <a:xfrm>
-            <a:off x="7772400" y="4453128"/>
-            <a:ext cx="3867912" cy="388620"/>
+          <p:cNvPr id="40" name="Shape 38"/>
+          <p:cNvSpPr/>
+          <p:nvPr/>
+        </p:nvSpPr>
+        <p:spPr>
+          <a:xfrm>
+            <a:off x="7772400" y="4878324"/>
+            <a:ext cx="3867912" cy="459486"/>
           </a:xfrm>
           <a:prstGeom prst="roundRect">
             <a:avLst>
-              <a:gd name="adj" fmla="val 14118"/>
+              <a:gd name="adj" fmla="val 11940"/>
             </a:avLst>
           </a:prstGeom>
           <a:solidFill>
@@ -6079,14 +6081,14 @@
       </p:sp>
       <p:sp>
         <p:nvSpPr>
-          <p:cNvPr id="40" name="Text 38"/>
-          <p:cNvSpPr/>
-          <p:nvPr/>
-        </p:nvSpPr>
-        <p:spPr>
-          <a:xfrm>
-            <a:off x="7845552" y="4453128"/>
-            <a:ext cx="297180" cy="388620"/>
+          <p:cNvPr id="41" name="Text 39"/>
+          <p:cNvSpPr/>
+          <p:nvPr/>
+        </p:nvSpPr>
+        <p:spPr>
+          <a:xfrm>
+            <a:off x="7845552" y="4878324"/>
+            <a:ext cx="329184" cy="459486"/>
           </a:xfrm>
           <a:prstGeom prst="rect">
             <a:avLst/>
@@ -6102,27 +6104,27 @@
               <a:buNone/>
             </a:pPr>
             <a:r>
-              <a:rPr lang="en-US" sz="1000" dirty="0">
+              <a:rPr lang="en-US" sz="1100" dirty="0">
                 <a:solidFill>
                   <a:srgbClr val="000000"/>
                 </a:solidFill>
               </a:rPr>
               <a:t>🏘️</a:t>
             </a:r>
-            <a:endParaRPr lang="en-US" sz="1000" dirty="0"/>
-          </a:p>
-        </p:txBody>
-      </p:sp>
-      <p:sp>
-        <p:nvSpPr>
-          <p:cNvPr id="41" name="Text 39"/>
-          <p:cNvSpPr/>
-          <p:nvPr/>
-        </p:nvSpPr>
-        <p:spPr>
-          <a:xfrm>
-            <a:off x="8234172" y="4471416"/>
-            <a:ext cx="3296412" cy="352044"/>
+            <a:endParaRPr lang="en-US" sz="1100" dirty="0"/>
+          </a:p>
+        </p:txBody>
+      </p:sp>
+      <p:sp>
+        <p:nvSpPr>
+          <p:cNvPr id="42" name="Text 40"/>
+          <p:cNvSpPr/>
+          <p:nvPr/>
+        </p:nvSpPr>
+        <p:spPr>
+          <a:xfrm>
+            <a:off x="8266176" y="4896612"/>
+            <a:ext cx="3264408" cy="422910"/>
           </a:xfrm>
           <a:prstGeom prst="rect">
             <a:avLst/>
@@ -6177,18 +6179,18 @@
       </p:sp>
       <p:sp>
         <p:nvSpPr>
-          <p:cNvPr id="42" name="Shape 40"/>
-          <p:cNvSpPr/>
-          <p:nvPr/>
-        </p:nvSpPr>
-        <p:spPr>
-          <a:xfrm>
-            <a:off x="7772400" y="4933188"/>
-            <a:ext cx="3867912" cy="388620"/>
+          <p:cNvPr id="43" name="Shape 41"/>
+          <p:cNvSpPr/>
+          <p:nvPr/>
+        </p:nvSpPr>
+        <p:spPr>
+          <a:xfrm>
+            <a:off x="7772400" y="5429250"/>
+            <a:ext cx="3867912" cy="459486"/>
           </a:xfrm>
           <a:prstGeom prst="roundRect">
             <a:avLst>
-              <a:gd name="adj" fmla="val 14118"/>
+              <a:gd name="adj" fmla="val 11940"/>
             </a:avLst>
           </a:prstGeom>
           <a:solidFill>
@@ -6199,14 +6201,14 @@
       </p:sp>
       <p:sp>
         <p:nvSpPr>
-          <p:cNvPr id="43" name="Text 41"/>
-          <p:cNvSpPr/>
-          <p:nvPr/>
-        </p:nvSpPr>
-        <p:spPr>
-          <a:xfrm>
-            <a:off x="7845552" y="4933188"/>
-            <a:ext cx="297180" cy="388620"/>
+          <p:cNvPr id="44" name="Text 42"/>
+          <p:cNvSpPr/>
+          <p:nvPr/>
+        </p:nvSpPr>
+        <p:spPr>
+          <a:xfrm>
+            <a:off x="7845552" y="5429250"/>
+            <a:ext cx="329184" cy="459486"/>
           </a:xfrm>
           <a:prstGeom prst="rect">
             <a:avLst/>
@@ -6222,27 +6224,27 @@
               <a:buNone/>
             </a:pPr>
             <a:r>
-              <a:rPr lang="en-US" sz="1000" dirty="0">
+              <a:rPr lang="en-US" sz="1100" dirty="0">
                 <a:solidFill>
                   <a:srgbClr val="000000"/>
                 </a:solidFill>
               </a:rPr>
               <a:t>🚪</a:t>
             </a:r>
-            <a:endParaRPr lang="en-US" sz="1000" dirty="0"/>
-          </a:p>
-        </p:txBody>
-      </p:sp>
-      <p:sp>
-        <p:nvSpPr>
-          <p:cNvPr id="44" name="Text 42"/>
-          <p:cNvSpPr/>
-          <p:nvPr/>
-        </p:nvSpPr>
-        <p:spPr>
-          <a:xfrm>
-            <a:off x="8234172" y="4951476"/>
-            <a:ext cx="3296412" cy="352044"/>
+            <a:endParaRPr lang="en-US" sz="1100" dirty="0"/>
+          </a:p>
+        </p:txBody>
+      </p:sp>
+      <p:sp>
+        <p:nvSpPr>
+          <p:cNvPr id="45" name="Text 43"/>
+          <p:cNvSpPr/>
+          <p:nvPr/>
+        </p:nvSpPr>
+        <p:spPr>
+          <a:xfrm>
+            <a:off x="8266176" y="5447538"/>
+            <a:ext cx="3264408" cy="422910"/>
           </a:xfrm>
           <a:prstGeom prst="rect">
             <a:avLst/>
@@ -6297,7 +6299,7 @@
       </p:sp>
       <p:sp>
         <p:nvSpPr>
-          <p:cNvPr id="45" name="Text 43"/>
+          <p:cNvPr id="46" name="Text 44"/>
           <p:cNvSpPr/>
           <p:nvPr/>
         </p:nvSpPr>
@@ -6336,7 +6338,7 @@
       </p:sp>
       <p:sp>
         <p:nvSpPr>
-          <p:cNvPr id="46" name="Text 44"/>
+          <p:cNvPr id="47" name="Text 45"/>
           <p:cNvSpPr/>
           <p:nvPr/>
         </p:nvSpPr>
@@ -6740,7 +6742,7 @@
         </p:nvSpPr>
         <p:spPr>
           <a:xfrm>
-            <a:off x="3600907" y="2682850"/>
+            <a:off x="3600907" y="2554834"/>
             <a:ext cx="2485339" cy="274320"/>
           </a:xfrm>
           <a:prstGeom prst="rect">
@@ -6949,80 +6951,18 @@
       </p:sp>
       <p:sp>
         <p:nvSpPr>
-          <p:cNvPr id="20" name="Text 18"/>
+          <p:cNvPr id="20" name="Shape 18"/>
           <p:cNvSpPr/>
           <p:nvPr/>
         </p:nvSpPr>
         <p:spPr>
           <a:xfrm>
             <a:off x="548640" y="4700016"/>
-            <a:ext cx="6949440" cy="457200"/>
-          </a:xfrm>
-          <a:prstGeom prst="rect">
-            <a:avLst/>
-          </a:prstGeom>
-          <a:noFill/>
-          <a:ln/>
-        </p:spPr>
-        <p:txBody>
-          <a:bodyPr wrap="square" lIns="0" tIns="0" rIns="0" bIns="0" rtlCol="0" anchor="ctr"/>
-          <a:lstStyle/>
-          <a:p>
-            <a:pPr algn="ctr" indent="0" marL="0">
-              <a:lnSpc>
-                <a:spcPct val="110000"/>
-              </a:lnSpc>
-              <a:buNone/>
-            </a:pPr>
-            <a:r>
-              <a:rPr lang="en-US" sz="1150" i="1" dirty="0">
-                <a:solidFill>
-                  <a:srgbClr val="5C6690"/>
-                </a:solidFill>
-                <a:latin typeface="Calibri" pitchFamily="34" charset="0"/>
-                <a:ea typeface="Calibri" pitchFamily="34" charset="-122"/>
-                <a:cs typeface="Calibri" pitchFamily="34" charset="-120"/>
-              </a:rPr>
-              <a:t>Empezada en 1221, consagrada en 1260. Ampliada después con un grandioso</a:t>
-            </a:r>
-            <a:endParaRPr lang="en-US" sz="1150" dirty="0"/>
-          </a:p>
-          <a:p>
-            <a:pPr algn="ctr" indent="0" marL="0">
-              <a:lnSpc>
-                <a:spcPct val="110000"/>
-              </a:lnSpc>
-              <a:buNone/>
-            </a:pPr>
-            <a:r>
-              <a:rPr lang="en-US" sz="1150" i="1" dirty="0">
-                <a:solidFill>
-                  <a:srgbClr val="5C6690"/>
-                </a:solidFill>
-                <a:latin typeface="Calibri" pitchFamily="34" charset="0"/>
-                <a:ea typeface="Calibri" pitchFamily="34" charset="-122"/>
-                <a:cs typeface="Calibri" pitchFamily="34" charset="-120"/>
-              </a:rPr>
-              <a:t>claustro, numerosas capillas, esbeltas agujas y un espléndido cimborrio.</a:t>
-            </a:r>
-            <a:endParaRPr lang="en-US" sz="1150" dirty="0"/>
-          </a:p>
-        </p:txBody>
-      </p:sp>
-      <p:sp>
-        <p:nvSpPr>
-          <p:cNvPr id="21" name="Shape 19"/>
-          <p:cNvSpPr/>
-          <p:nvPr/>
-        </p:nvSpPr>
-        <p:spPr>
-          <a:xfrm>
-            <a:off x="7772400" y="1572768"/>
-            <a:ext cx="3867912" cy="360045"/>
+            <a:ext cx="6949440" cy="960120"/>
           </a:xfrm>
           <a:prstGeom prst="roundRect">
             <a:avLst>
-              <a:gd name="adj" fmla="val 15238"/>
+              <a:gd name="adj" fmla="val 7619"/>
             </a:avLst>
           </a:prstGeom>
           <a:solidFill>
@@ -7033,14 +6973,78 @@
       </p:sp>
       <p:sp>
         <p:nvSpPr>
-          <p:cNvPr id="22" name="Text 20"/>
+          <p:cNvPr id="21" name="Text 19"/>
+          <p:cNvSpPr/>
+          <p:nvPr/>
+        </p:nvSpPr>
+        <p:spPr>
+          <a:xfrm>
+            <a:off x="749808" y="4700016"/>
+            <a:ext cx="6547104" cy="960120"/>
+          </a:xfrm>
+          <a:prstGeom prst="rect">
+            <a:avLst/>
+          </a:prstGeom>
+          <a:noFill/>
+          <a:ln/>
+        </p:spPr>
+        <p:txBody>
+          <a:bodyPr wrap="square" lIns="0" tIns="0" rIns="0" bIns="0" rtlCol="0" anchor="ctr"/>
+          <a:lstStyle/>
+          <a:p>
+            <a:pPr algn="l" indent="0" marL="0">
+              <a:lnSpc>
+                <a:spcPct val="112000"/>
+              </a:lnSpc>
+              <a:buNone/>
+            </a:pPr>
+            <a:r>
+              <a:rPr lang="en-US" sz="1050" dirty="0">
+                <a:solidFill>
+                  <a:srgbClr val="2F3C7E"/>
+                </a:solidFill>
+                <a:latin typeface="Calibri" pitchFamily="34" charset="0"/>
+                <a:ea typeface="Calibri" pitchFamily="34" charset="-122"/>
+                <a:cs typeface="Calibri" pitchFamily="34" charset="-120"/>
+              </a:rPr>
+              <a:t>El gótico (s. XII-XVI) nació en Francia buscando altura y luz: arcos apuntados y contrafuertes permitieron muros más finos y grandes vidrieras. La catedral de Burgos se empezó en 1221 y se consagró en 1260; después se amplió con un grandioso claustro, numerosas capillas, esbeltas agujas y un espléndido cimborrio.</a:t>
+            </a:r>
+            <a:endParaRPr lang="en-US" sz="1050" dirty="0"/>
+          </a:p>
+        </p:txBody>
+      </p:sp>
+      <p:sp>
+        <p:nvSpPr>
+          <p:cNvPr id="22" name="Shape 20"/>
+          <p:cNvSpPr/>
+          <p:nvPr/>
+        </p:nvSpPr>
+        <p:spPr>
+          <a:xfrm>
+            <a:off x="7772400" y="1572768"/>
+            <a:ext cx="3867912" cy="430911"/>
+          </a:xfrm>
+          <a:prstGeom prst="roundRect">
+            <a:avLst>
+              <a:gd name="adj" fmla="val 12732"/>
+            </a:avLst>
+          </a:prstGeom>
+          <a:solidFill>
+            <a:srgbClr val="F5F6FB"/>
+          </a:solidFill>
+          <a:ln/>
+        </p:spPr>
+      </p:sp>
+      <p:sp>
+        <p:nvSpPr>
+          <p:cNvPr id="23" name="Text 21"/>
           <p:cNvSpPr/>
           <p:nvPr/>
         </p:nvSpPr>
         <p:spPr>
           <a:xfrm>
             <a:off x="7845552" y="1572768"/>
-            <a:ext cx="268605" cy="360045"/>
+            <a:ext cx="329184" cy="430911"/>
           </a:xfrm>
           <a:prstGeom prst="rect">
             <a:avLst/>
@@ -7056,27 +7060,27 @@
               <a:buNone/>
             </a:pPr>
             <a:r>
-              <a:rPr lang="en-US" sz="900" dirty="0">
+              <a:rPr lang="en-US" sz="1100" dirty="0">
                 <a:solidFill>
                   <a:srgbClr val="000000"/>
                 </a:solidFill>
               </a:rPr>
               <a:t>⛪</a:t>
             </a:r>
-            <a:endParaRPr lang="en-US" sz="900" dirty="0"/>
-          </a:p>
-        </p:txBody>
-      </p:sp>
-      <p:sp>
-        <p:nvSpPr>
-          <p:cNvPr id="23" name="Text 21"/>
-          <p:cNvSpPr/>
-          <p:nvPr/>
-        </p:nvSpPr>
-        <p:spPr>
-          <a:xfrm>
-            <a:off x="8205597" y="1591056"/>
-            <a:ext cx="3324987" cy="323469"/>
+            <a:endParaRPr lang="en-US" sz="1100" dirty="0"/>
+          </a:p>
+        </p:txBody>
+      </p:sp>
+      <p:sp>
+        <p:nvSpPr>
+          <p:cNvPr id="24" name="Text 22"/>
+          <p:cNvSpPr/>
+          <p:nvPr/>
+        </p:nvSpPr>
+        <p:spPr>
+          <a:xfrm>
+            <a:off x="8266176" y="1591056"/>
+            <a:ext cx="3264408" cy="394335"/>
           </a:xfrm>
           <a:prstGeom prst="rect">
             <a:avLst/>
@@ -7131,18 +7135,18 @@
       </p:sp>
       <p:sp>
         <p:nvSpPr>
-          <p:cNvPr id="24" name="Shape 22"/>
-          <p:cNvSpPr/>
-          <p:nvPr/>
-        </p:nvSpPr>
-        <p:spPr>
-          <a:xfrm>
-            <a:off x="7772400" y="2024253"/>
-            <a:ext cx="3867912" cy="360045"/>
+          <p:cNvPr id="25" name="Shape 23"/>
+          <p:cNvSpPr/>
+          <p:nvPr/>
+        </p:nvSpPr>
+        <p:spPr>
+          <a:xfrm>
+            <a:off x="7772400" y="2095119"/>
+            <a:ext cx="3867912" cy="430911"/>
           </a:xfrm>
           <a:prstGeom prst="roundRect">
             <a:avLst>
-              <a:gd name="adj" fmla="val 15238"/>
+              <a:gd name="adj" fmla="val 12732"/>
             </a:avLst>
           </a:prstGeom>
           <a:solidFill>
@@ -7153,14 +7157,14 @@
       </p:sp>
       <p:sp>
         <p:nvSpPr>
-          <p:cNvPr id="25" name="Text 23"/>
-          <p:cNvSpPr/>
-          <p:nvPr/>
-        </p:nvSpPr>
-        <p:spPr>
-          <a:xfrm>
-            <a:off x="7845552" y="2024253"/>
-            <a:ext cx="268605" cy="360045"/>
+          <p:cNvPr id="26" name="Text 24"/>
+          <p:cNvSpPr/>
+          <p:nvPr/>
+        </p:nvSpPr>
+        <p:spPr>
+          <a:xfrm>
+            <a:off x="7845552" y="2095119"/>
+            <a:ext cx="329184" cy="430911"/>
           </a:xfrm>
           <a:prstGeom prst="rect">
             <a:avLst/>
@@ -7176,27 +7180,27 @@
               <a:buNone/>
             </a:pPr>
             <a:r>
-              <a:rPr lang="en-US" sz="900" dirty="0">
+              <a:rPr lang="en-US" sz="1100" dirty="0">
                 <a:solidFill>
                   <a:srgbClr val="000000"/>
                 </a:solidFill>
               </a:rPr>
               <a:t>🚶</a:t>
             </a:r>
-            <a:endParaRPr lang="en-US" sz="900" dirty="0"/>
-          </a:p>
-        </p:txBody>
-      </p:sp>
-      <p:sp>
-        <p:nvSpPr>
-          <p:cNvPr id="26" name="Text 24"/>
-          <p:cNvSpPr/>
-          <p:nvPr/>
-        </p:nvSpPr>
-        <p:spPr>
-          <a:xfrm>
-            <a:off x="8205597" y="2042541"/>
-            <a:ext cx="3324987" cy="323469"/>
+            <a:endParaRPr lang="en-US" sz="1100" dirty="0"/>
+          </a:p>
+        </p:txBody>
+      </p:sp>
+      <p:sp>
+        <p:nvSpPr>
+          <p:cNvPr id="27" name="Text 25"/>
+          <p:cNvSpPr/>
+          <p:nvPr/>
+        </p:nvSpPr>
+        <p:spPr>
+          <a:xfrm>
+            <a:off x="8266176" y="2113407"/>
+            <a:ext cx="3264408" cy="394335"/>
           </a:xfrm>
           <a:prstGeom prst="rect">
             <a:avLst/>
@@ -7251,18 +7255,18 @@
       </p:sp>
       <p:sp>
         <p:nvSpPr>
-          <p:cNvPr id="27" name="Shape 25"/>
-          <p:cNvSpPr/>
-          <p:nvPr/>
-        </p:nvSpPr>
-        <p:spPr>
-          <a:xfrm>
-            <a:off x="7772400" y="2475738"/>
-            <a:ext cx="3867912" cy="360045"/>
+          <p:cNvPr id="28" name="Shape 26"/>
+          <p:cNvSpPr/>
+          <p:nvPr/>
+        </p:nvSpPr>
+        <p:spPr>
+          <a:xfrm>
+            <a:off x="7772400" y="2617470"/>
+            <a:ext cx="3867912" cy="430911"/>
           </a:xfrm>
           <a:prstGeom prst="roundRect">
             <a:avLst>
-              <a:gd name="adj" fmla="val 15238"/>
+              <a:gd name="adj" fmla="val 12732"/>
             </a:avLst>
           </a:prstGeom>
           <a:solidFill>
@@ -7273,14 +7277,14 @@
       </p:sp>
       <p:sp>
         <p:nvSpPr>
-          <p:cNvPr id="28" name="Text 26"/>
-          <p:cNvSpPr/>
-          <p:nvPr/>
-        </p:nvSpPr>
-        <p:spPr>
-          <a:xfrm>
-            <a:off x="7845552" y="2475738"/>
-            <a:ext cx="268605" cy="360045"/>
+          <p:cNvPr id="29" name="Text 27"/>
+          <p:cNvSpPr/>
+          <p:nvPr/>
+        </p:nvSpPr>
+        <p:spPr>
+          <a:xfrm>
+            <a:off x="7845552" y="2617470"/>
+            <a:ext cx="329184" cy="430911"/>
           </a:xfrm>
           <a:prstGeom prst="rect">
             <a:avLst/>
@@ -7296,27 +7300,27 @@
               <a:buNone/>
             </a:pPr>
             <a:r>
-              <a:rPr lang="en-US" sz="900" dirty="0">
+              <a:rPr lang="en-US" sz="1100" dirty="0">
                 <a:solidFill>
                   <a:srgbClr val="000000"/>
                 </a:solidFill>
               </a:rPr>
               <a:t>🙏</a:t>
             </a:r>
-            <a:endParaRPr lang="en-US" sz="900" dirty="0"/>
-          </a:p>
-        </p:txBody>
-      </p:sp>
-      <p:sp>
-        <p:nvSpPr>
-          <p:cNvPr id="29" name="Text 27"/>
-          <p:cNvSpPr/>
-          <p:nvPr/>
-        </p:nvSpPr>
-        <p:spPr>
-          <a:xfrm>
-            <a:off x="8205597" y="2494026"/>
-            <a:ext cx="3324987" cy="323469"/>
+            <a:endParaRPr lang="en-US" sz="1100" dirty="0"/>
+          </a:p>
+        </p:txBody>
+      </p:sp>
+      <p:sp>
+        <p:nvSpPr>
+          <p:cNvPr id="30" name="Text 28"/>
+          <p:cNvSpPr/>
+          <p:nvPr/>
+        </p:nvSpPr>
+        <p:spPr>
+          <a:xfrm>
+            <a:off x="8266176" y="2635758"/>
+            <a:ext cx="3264408" cy="394335"/>
           </a:xfrm>
           <a:prstGeom prst="rect">
             <a:avLst/>
@@ -7371,18 +7375,18 @@
       </p:sp>
       <p:sp>
         <p:nvSpPr>
-          <p:cNvPr id="30" name="Shape 28"/>
-          <p:cNvSpPr/>
-          <p:nvPr/>
-        </p:nvSpPr>
-        <p:spPr>
-          <a:xfrm>
-            <a:off x="7772400" y="2927223"/>
-            <a:ext cx="3867912" cy="360045"/>
+          <p:cNvPr id="31" name="Shape 29"/>
+          <p:cNvSpPr/>
+          <p:nvPr/>
+        </p:nvSpPr>
+        <p:spPr>
+          <a:xfrm>
+            <a:off x="7772400" y="3139821"/>
+            <a:ext cx="3867912" cy="430911"/>
           </a:xfrm>
           <a:prstGeom prst="roundRect">
             <a:avLst>
-              <a:gd name="adj" fmla="val 15238"/>
+              <a:gd name="adj" fmla="val 12732"/>
             </a:avLst>
           </a:prstGeom>
           <a:solidFill>
@@ -7393,14 +7397,14 @@
       </p:sp>
       <p:sp>
         <p:nvSpPr>
-          <p:cNvPr id="31" name="Text 29"/>
-          <p:cNvSpPr/>
-          <p:nvPr/>
-        </p:nvSpPr>
-        <p:spPr>
-          <a:xfrm>
-            <a:off x="7845552" y="2927223"/>
-            <a:ext cx="268605" cy="360045"/>
+          <p:cNvPr id="32" name="Text 30"/>
+          <p:cNvSpPr/>
+          <p:nvPr/>
+        </p:nvSpPr>
+        <p:spPr>
+          <a:xfrm>
+            <a:off x="7845552" y="3139821"/>
+            <a:ext cx="329184" cy="430911"/>
           </a:xfrm>
           <a:prstGeom prst="rect">
             <a:avLst/>
@@ -7416,27 +7420,27 @@
               <a:buNone/>
             </a:pPr>
             <a:r>
-              <a:rPr lang="en-US" sz="900" dirty="0">
+              <a:rPr lang="en-US" sz="1100" dirty="0">
                 <a:solidFill>
                   <a:srgbClr val="000000"/>
                 </a:solidFill>
               </a:rPr>
               <a:t>🗼</a:t>
             </a:r>
-            <a:endParaRPr lang="en-US" sz="900" dirty="0"/>
-          </a:p>
-        </p:txBody>
-      </p:sp>
-      <p:sp>
-        <p:nvSpPr>
-          <p:cNvPr id="32" name="Text 30"/>
-          <p:cNvSpPr/>
-          <p:nvPr/>
-        </p:nvSpPr>
-        <p:spPr>
-          <a:xfrm>
-            <a:off x="8205597" y="2945511"/>
-            <a:ext cx="3324987" cy="323469"/>
+            <a:endParaRPr lang="en-US" sz="1100" dirty="0"/>
+          </a:p>
+        </p:txBody>
+      </p:sp>
+      <p:sp>
+        <p:nvSpPr>
+          <p:cNvPr id="33" name="Text 31"/>
+          <p:cNvSpPr/>
+          <p:nvPr/>
+        </p:nvSpPr>
+        <p:spPr>
+          <a:xfrm>
+            <a:off x="8266176" y="3158109"/>
+            <a:ext cx="3264408" cy="394335"/>
           </a:xfrm>
           <a:prstGeom prst="rect">
             <a:avLst/>
@@ -7491,18 +7495,18 @@
       </p:sp>
       <p:sp>
         <p:nvSpPr>
-          <p:cNvPr id="33" name="Shape 31"/>
-          <p:cNvSpPr/>
-          <p:nvPr/>
-        </p:nvSpPr>
-        <p:spPr>
-          <a:xfrm>
-            <a:off x="7772400" y="3378708"/>
-            <a:ext cx="3867912" cy="360045"/>
+          <p:cNvPr id="34" name="Shape 32"/>
+          <p:cNvSpPr/>
+          <p:nvPr/>
+        </p:nvSpPr>
+        <p:spPr>
+          <a:xfrm>
+            <a:off x="7772400" y="3662172"/>
+            <a:ext cx="3867912" cy="430911"/>
           </a:xfrm>
           <a:prstGeom prst="roundRect">
             <a:avLst>
-              <a:gd name="adj" fmla="val 15238"/>
+              <a:gd name="adj" fmla="val 12732"/>
             </a:avLst>
           </a:prstGeom>
           <a:solidFill>
@@ -7513,14 +7517,14 @@
       </p:sp>
       <p:sp>
         <p:nvSpPr>
-          <p:cNvPr id="34" name="Text 32"/>
-          <p:cNvSpPr/>
-          <p:nvPr/>
-        </p:nvSpPr>
-        <p:spPr>
-          <a:xfrm>
-            <a:off x="7845552" y="3378708"/>
-            <a:ext cx="268605" cy="360045"/>
+          <p:cNvPr id="35" name="Text 33"/>
+          <p:cNvSpPr/>
+          <p:nvPr/>
+        </p:nvSpPr>
+        <p:spPr>
+          <a:xfrm>
+            <a:off x="7845552" y="3662172"/>
+            <a:ext cx="329184" cy="430911"/>
           </a:xfrm>
           <a:prstGeom prst="rect">
             <a:avLst/>
@@ -7536,27 +7540,27 @@
               <a:buNone/>
             </a:pPr>
             <a:r>
-              <a:rPr lang="en-US" sz="900" dirty="0">
+              <a:rPr lang="en-US" sz="1100" dirty="0">
                 <a:solidFill>
                   <a:srgbClr val="000000"/>
                 </a:solidFill>
               </a:rPr>
               <a:t>🏯</a:t>
             </a:r>
-            <a:endParaRPr lang="en-US" sz="900" dirty="0"/>
-          </a:p>
-        </p:txBody>
-      </p:sp>
-      <p:sp>
-        <p:nvSpPr>
-          <p:cNvPr id="35" name="Text 33"/>
-          <p:cNvSpPr/>
-          <p:nvPr/>
-        </p:nvSpPr>
-        <p:spPr>
-          <a:xfrm>
-            <a:off x="8205597" y="3396996"/>
-            <a:ext cx="3324987" cy="323469"/>
+            <a:endParaRPr lang="en-US" sz="1100" dirty="0"/>
+          </a:p>
+        </p:txBody>
+      </p:sp>
+      <p:sp>
+        <p:nvSpPr>
+          <p:cNvPr id="36" name="Text 34"/>
+          <p:cNvSpPr/>
+          <p:nvPr/>
+        </p:nvSpPr>
+        <p:spPr>
+          <a:xfrm>
+            <a:off x="8266176" y="3680460"/>
+            <a:ext cx="3264408" cy="394335"/>
           </a:xfrm>
           <a:prstGeom prst="rect">
             <a:avLst/>
@@ -7611,18 +7615,18 @@
       </p:sp>
       <p:sp>
         <p:nvSpPr>
-          <p:cNvPr id="36" name="Shape 34"/>
-          <p:cNvSpPr/>
-          <p:nvPr/>
-        </p:nvSpPr>
-        <p:spPr>
-          <a:xfrm>
-            <a:off x="7772400" y="3830193"/>
-            <a:ext cx="3867912" cy="360045"/>
+          <p:cNvPr id="37" name="Shape 35"/>
+          <p:cNvSpPr/>
+          <p:nvPr/>
+        </p:nvSpPr>
+        <p:spPr>
+          <a:xfrm>
+            <a:off x="7772400" y="4184523"/>
+            <a:ext cx="3867912" cy="430911"/>
           </a:xfrm>
           <a:prstGeom prst="roundRect">
             <a:avLst>
-              <a:gd name="adj" fmla="val 15238"/>
+              <a:gd name="adj" fmla="val 12732"/>
             </a:avLst>
           </a:prstGeom>
           <a:solidFill>
@@ -7633,14 +7637,14 @@
       </p:sp>
       <p:sp>
         <p:nvSpPr>
-          <p:cNvPr id="37" name="Text 35"/>
-          <p:cNvSpPr/>
-          <p:nvPr/>
-        </p:nvSpPr>
-        <p:spPr>
-          <a:xfrm>
-            <a:off x="7845552" y="3830193"/>
-            <a:ext cx="268605" cy="360045"/>
+          <p:cNvPr id="38" name="Text 36"/>
+          <p:cNvSpPr/>
+          <p:nvPr/>
+        </p:nvSpPr>
+        <p:spPr>
+          <a:xfrm>
+            <a:off x="7845552" y="4184523"/>
+            <a:ext cx="329184" cy="430911"/>
           </a:xfrm>
           <a:prstGeom prst="rect">
             <a:avLst/>
@@ -7656,27 +7660,27 @@
               <a:buNone/>
             </a:pPr>
             <a:r>
-              <a:rPr lang="en-US" sz="900" dirty="0">
+              <a:rPr lang="en-US" sz="1100" dirty="0">
                 <a:solidFill>
                   <a:srgbClr val="000000"/>
                 </a:solidFill>
               </a:rPr>
               <a:t>🎉</a:t>
             </a:r>
-            <a:endParaRPr lang="en-US" sz="900" dirty="0"/>
-          </a:p>
-        </p:txBody>
-      </p:sp>
-      <p:sp>
-        <p:nvSpPr>
-          <p:cNvPr id="38" name="Text 36"/>
-          <p:cNvSpPr/>
-          <p:nvPr/>
-        </p:nvSpPr>
-        <p:spPr>
-          <a:xfrm>
-            <a:off x="8205597" y="3848481"/>
-            <a:ext cx="3324987" cy="323469"/>
+            <a:endParaRPr lang="en-US" sz="1100" dirty="0"/>
+          </a:p>
+        </p:txBody>
+      </p:sp>
+      <p:sp>
+        <p:nvSpPr>
+          <p:cNvPr id="39" name="Text 37"/>
+          <p:cNvSpPr/>
+          <p:nvPr/>
+        </p:nvSpPr>
+        <p:spPr>
+          <a:xfrm>
+            <a:off x="8266176" y="4202811"/>
+            <a:ext cx="3264408" cy="394335"/>
           </a:xfrm>
           <a:prstGeom prst="rect">
             <a:avLst/>
@@ -7731,18 +7735,18 @@
       </p:sp>
       <p:sp>
         <p:nvSpPr>
-          <p:cNvPr id="39" name="Shape 37"/>
-          <p:cNvSpPr/>
-          <p:nvPr/>
-        </p:nvSpPr>
-        <p:spPr>
-          <a:xfrm>
-            <a:off x="7772400" y="4281678"/>
-            <a:ext cx="3867912" cy="360045"/>
+          <p:cNvPr id="40" name="Shape 38"/>
+          <p:cNvSpPr/>
+          <p:nvPr/>
+        </p:nvSpPr>
+        <p:spPr>
+          <a:xfrm>
+            <a:off x="7772400" y="4706874"/>
+            <a:ext cx="3867912" cy="430911"/>
           </a:xfrm>
           <a:prstGeom prst="roundRect">
             <a:avLst>
-              <a:gd name="adj" fmla="val 15238"/>
+              <a:gd name="adj" fmla="val 12732"/>
             </a:avLst>
           </a:prstGeom>
           <a:solidFill>
@@ -7753,14 +7757,14 @@
       </p:sp>
       <p:sp>
         <p:nvSpPr>
-          <p:cNvPr id="40" name="Text 38"/>
-          <p:cNvSpPr/>
-          <p:nvPr/>
-        </p:nvSpPr>
-        <p:spPr>
-          <a:xfrm>
-            <a:off x="7845552" y="4281678"/>
-            <a:ext cx="268605" cy="360045"/>
+          <p:cNvPr id="41" name="Text 39"/>
+          <p:cNvSpPr/>
+          <p:nvPr/>
+        </p:nvSpPr>
+        <p:spPr>
+          <a:xfrm>
+            <a:off x="7845552" y="4706874"/>
+            <a:ext cx="329184" cy="430911"/>
           </a:xfrm>
           <a:prstGeom prst="rect">
             <a:avLst/>
@@ -7776,27 +7780,27 @@
               <a:buNone/>
             </a:pPr>
             <a:r>
-              <a:rPr lang="en-US" sz="900" dirty="0">
+              <a:rPr lang="en-US" sz="1100" dirty="0">
                 <a:solidFill>
                   <a:srgbClr val="000000"/>
                 </a:solidFill>
               </a:rPr>
               <a:t>📈</a:t>
             </a:r>
-            <a:endParaRPr lang="en-US" sz="900" dirty="0"/>
-          </a:p>
-        </p:txBody>
-      </p:sp>
-      <p:sp>
-        <p:nvSpPr>
-          <p:cNvPr id="41" name="Text 39"/>
-          <p:cNvSpPr/>
-          <p:nvPr/>
-        </p:nvSpPr>
-        <p:spPr>
-          <a:xfrm>
-            <a:off x="8205597" y="4299966"/>
-            <a:ext cx="3324987" cy="323469"/>
+            <a:endParaRPr lang="en-US" sz="1100" dirty="0"/>
+          </a:p>
+        </p:txBody>
+      </p:sp>
+      <p:sp>
+        <p:nvSpPr>
+          <p:cNvPr id="42" name="Text 40"/>
+          <p:cNvSpPr/>
+          <p:nvPr/>
+        </p:nvSpPr>
+        <p:spPr>
+          <a:xfrm>
+            <a:off x="8266176" y="4725162"/>
+            <a:ext cx="3264408" cy="394335"/>
           </a:xfrm>
           <a:prstGeom prst="rect">
             <a:avLst/>
@@ -7851,18 +7855,18 @@
       </p:sp>
       <p:sp>
         <p:nvSpPr>
-          <p:cNvPr id="42" name="Shape 40"/>
-          <p:cNvSpPr/>
-          <p:nvPr/>
-        </p:nvSpPr>
-        <p:spPr>
-          <a:xfrm>
-            <a:off x="7772400" y="4733163"/>
-            <a:ext cx="3867912" cy="360045"/>
+          <p:cNvPr id="43" name="Shape 41"/>
+          <p:cNvSpPr/>
+          <p:nvPr/>
+        </p:nvSpPr>
+        <p:spPr>
+          <a:xfrm>
+            <a:off x="7772400" y="5229225"/>
+            <a:ext cx="3867912" cy="430911"/>
           </a:xfrm>
           <a:prstGeom prst="roundRect">
             <a:avLst>
-              <a:gd name="adj" fmla="val 15238"/>
+              <a:gd name="adj" fmla="val 12732"/>
             </a:avLst>
           </a:prstGeom>
           <a:solidFill>
@@ -7873,14 +7877,14 @@
       </p:sp>
       <p:sp>
         <p:nvSpPr>
-          <p:cNvPr id="43" name="Text 41"/>
-          <p:cNvSpPr/>
-          <p:nvPr/>
-        </p:nvSpPr>
-        <p:spPr>
-          <a:xfrm>
-            <a:off x="7845552" y="4733163"/>
-            <a:ext cx="268605" cy="360045"/>
+          <p:cNvPr id="44" name="Text 42"/>
+          <p:cNvSpPr/>
+          <p:nvPr/>
+        </p:nvSpPr>
+        <p:spPr>
+          <a:xfrm>
+            <a:off x="7845552" y="5229225"/>
+            <a:ext cx="329184" cy="430911"/>
           </a:xfrm>
           <a:prstGeom prst="rect">
             <a:avLst/>
@@ -7896,27 +7900,27 @@
               <a:buNone/>
             </a:pPr>
             <a:r>
-              <a:rPr lang="en-US" sz="900" dirty="0">
+              <a:rPr lang="en-US" sz="1100" dirty="0">
                 <a:solidFill>
                   <a:srgbClr val="000000"/>
                 </a:solidFill>
               </a:rPr>
               <a:t>✨</a:t>
             </a:r>
-            <a:endParaRPr lang="en-US" sz="900" dirty="0"/>
-          </a:p>
-        </p:txBody>
-      </p:sp>
-      <p:sp>
-        <p:nvSpPr>
-          <p:cNvPr id="44" name="Text 42"/>
-          <p:cNvSpPr/>
-          <p:nvPr/>
-        </p:nvSpPr>
-        <p:spPr>
-          <a:xfrm>
-            <a:off x="8205597" y="4751451"/>
-            <a:ext cx="3324987" cy="323469"/>
+            <a:endParaRPr lang="en-US" sz="1100" dirty="0"/>
+          </a:p>
+        </p:txBody>
+      </p:sp>
+      <p:sp>
+        <p:nvSpPr>
+          <p:cNvPr id="45" name="Text 43"/>
+          <p:cNvSpPr/>
+          <p:nvPr/>
+        </p:nvSpPr>
+        <p:spPr>
+          <a:xfrm>
+            <a:off x="8266176" y="5247513"/>
+            <a:ext cx="3264408" cy="394335"/>
           </a:xfrm>
           <a:prstGeom prst="rect">
             <a:avLst/>
@@ -7971,7 +7975,7 @@
       </p:sp>
       <p:sp>
         <p:nvSpPr>
-          <p:cNvPr id="45" name="Text 43"/>
+          <p:cNvPr id="46" name="Text 44"/>
           <p:cNvSpPr/>
           <p:nvPr/>
         </p:nvSpPr>
@@ -8010,7 +8014,7 @@
       </p:sp>
       <p:sp>
         <p:nvSpPr>
-          <p:cNvPr id="46" name="Text 44"/>
+          <p:cNvPr id="47" name="Text 45"/>
           <p:cNvSpPr/>
           <p:nvPr/>
         </p:nvSpPr>
@@ -8623,80 +8627,18 @@
       </p:sp>
       <p:sp>
         <p:nvSpPr>
-          <p:cNvPr id="20" name="Text 18"/>
+          <p:cNvPr id="20" name="Shape 18"/>
           <p:cNvSpPr/>
           <p:nvPr/>
         </p:nvSpPr>
         <p:spPr>
           <a:xfrm>
             <a:off x="548640" y="5340096"/>
-            <a:ext cx="6949440" cy="457200"/>
-          </a:xfrm>
-          <a:prstGeom prst="rect">
-            <a:avLst/>
-          </a:prstGeom>
-          <a:noFill/>
-          <a:ln/>
-        </p:spPr>
-        <p:txBody>
-          <a:bodyPr wrap="square" lIns="0" tIns="0" rIns="0" bIns="0" rtlCol="0" anchor="ctr"/>
-          <a:lstStyle/>
-          <a:p>
-            <a:pPr algn="ctr" indent="0" marL="0">
-              <a:lnSpc>
-                <a:spcPct val="110000"/>
-              </a:lnSpc>
-              <a:buNone/>
-            </a:pPr>
-            <a:r>
-              <a:rPr lang="en-US" sz="1150" i="1" dirty="0">
-                <a:solidFill>
-                  <a:srgbClr val="5C6690"/>
-                </a:solidFill>
-                <a:latin typeface="Calibri" pitchFamily="34" charset="0"/>
-                <a:ea typeface="Calibri" pitchFamily="34" charset="-122"/>
-                <a:cs typeface="Calibri" pitchFamily="34" charset="-120"/>
-              </a:rPr>
-              <a:t>Mide 97,5 m. Dos torres, una dentro de la otra, con una rampa en el hueco</a:t>
-            </a:r>
-            <a:endParaRPr lang="en-US" sz="1150" dirty="0"/>
-          </a:p>
-          <a:p>
-            <a:pPr algn="ctr" indent="0" marL="0">
-              <a:lnSpc>
-                <a:spcPct val="110000"/>
-              </a:lnSpc>
-              <a:buNone/>
-            </a:pPr>
-            <a:r>
-              <a:rPr lang="en-US" sz="1150" i="1" dirty="0">
-                <a:solidFill>
-                  <a:srgbClr val="5C6690"/>
-                </a:solidFill>
-                <a:latin typeface="Calibri" pitchFamily="34" charset="0"/>
-                <a:ea typeface="Calibri" pitchFamily="34" charset="-122"/>
-                <a:cs typeface="Calibri" pitchFamily="34" charset="-120"/>
-              </a:rPr>
-              <a:t>para subir a caballo. Encima, cuerpo de campanas renacentista y veleta giratoria.</a:t>
-            </a:r>
-            <a:endParaRPr lang="en-US" sz="1150" dirty="0"/>
-          </a:p>
-        </p:txBody>
-      </p:sp>
-      <p:sp>
-        <p:nvSpPr>
-          <p:cNvPr id="21" name="Shape 19"/>
-          <p:cNvSpPr/>
-          <p:nvPr/>
-        </p:nvSpPr>
-        <p:spPr>
-          <a:xfrm>
-            <a:off x="7772400" y="1572768"/>
-            <a:ext cx="3867912" cy="515983"/>
+            <a:ext cx="6949440" cy="960120"/>
           </a:xfrm>
           <a:prstGeom prst="roundRect">
             <a:avLst>
-              <a:gd name="adj" fmla="val 10633"/>
+              <a:gd name="adj" fmla="val 7619"/>
             </a:avLst>
           </a:prstGeom>
           <a:solidFill>
@@ -8707,14 +8649,78 @@
       </p:sp>
       <p:sp>
         <p:nvSpPr>
-          <p:cNvPr id="22" name="Text 20"/>
+          <p:cNvPr id="21" name="Text 19"/>
+          <p:cNvSpPr/>
+          <p:nvPr/>
+        </p:nvSpPr>
+        <p:spPr>
+          <a:xfrm>
+            <a:off x="749808" y="5340096"/>
+            <a:ext cx="6547104" cy="960120"/>
+          </a:xfrm>
+          <a:prstGeom prst="rect">
+            <a:avLst/>
+          </a:prstGeom>
+          <a:noFill/>
+          <a:ln/>
+        </p:spPr>
+        <p:txBody>
+          <a:bodyPr wrap="square" lIns="0" tIns="0" rIns="0" bIns="0" rtlCol="0" anchor="ctr"/>
+          <a:lstStyle/>
+          <a:p>
+            <a:pPr algn="l" indent="0" marL="0">
+              <a:lnSpc>
+                <a:spcPct val="112000"/>
+              </a:lnSpc>
+              <a:buNone/>
+            </a:pPr>
+            <a:r>
+              <a:rPr lang="en-US" sz="1050" dirty="0">
+                <a:solidFill>
+                  <a:srgbClr val="2F3C7E"/>
+                </a:solidFill>
+                <a:latin typeface="Calibri" pitchFamily="34" charset="0"/>
+                <a:ea typeface="Calibri" pitchFamily="34" charset="-122"/>
+                <a:cs typeface="Calibri" pitchFamily="34" charset="-120"/>
+              </a:rPr>
+              <a:t>El arte árabe llegó a España con la conquista musulmana (711) y floreció casi 800 años en Al-Ándalus. La Giralda (97,5 m) era el minarete de la mezquita de Sevilla: dos torres, una dentro de la otra, con una rampa interior para subir a caballo; encima, cuerpo de campanas renacentista y veleta giratoria.</a:t>
+            </a:r>
+            <a:endParaRPr lang="en-US" sz="1050" dirty="0"/>
+          </a:p>
+        </p:txBody>
+      </p:sp>
+      <p:sp>
+        <p:nvSpPr>
+          <p:cNvPr id="22" name="Shape 20"/>
+          <p:cNvSpPr/>
+          <p:nvPr/>
+        </p:nvSpPr>
+        <p:spPr>
+          <a:xfrm>
+            <a:off x="7772400" y="1572768"/>
+            <a:ext cx="3867912" cy="596973"/>
+          </a:xfrm>
+          <a:prstGeom prst="roundRect">
+            <a:avLst>
+              <a:gd name="adj" fmla="val 9190"/>
+            </a:avLst>
+          </a:prstGeom>
+          <a:solidFill>
+            <a:srgbClr val="F5F6FB"/>
+          </a:solidFill>
+          <a:ln/>
+        </p:spPr>
+      </p:sp>
+      <p:sp>
+        <p:nvSpPr>
+          <p:cNvPr id="23" name="Text 21"/>
           <p:cNvSpPr/>
           <p:nvPr/>
         </p:nvSpPr>
         <p:spPr>
           <a:xfrm>
             <a:off x="7845552" y="1572768"/>
-            <a:ext cx="329184" cy="515983"/>
+            <a:ext cx="329184" cy="596973"/>
           </a:xfrm>
           <a:prstGeom prst="rect">
             <a:avLst/>
@@ -8743,14 +8749,14 @@
       </p:sp>
       <p:sp>
         <p:nvSpPr>
-          <p:cNvPr id="23" name="Text 21"/>
+          <p:cNvPr id="24" name="Text 22"/>
           <p:cNvSpPr/>
           <p:nvPr/>
         </p:nvSpPr>
         <p:spPr>
           <a:xfrm>
             <a:off x="8266176" y="1591056"/>
-            <a:ext cx="3264408" cy="479407"/>
+            <a:ext cx="3264408" cy="560397"/>
           </a:xfrm>
           <a:prstGeom prst="rect">
             <a:avLst/>
@@ -8805,18 +8811,18 @@
       </p:sp>
       <p:sp>
         <p:nvSpPr>
-          <p:cNvPr id="24" name="Shape 22"/>
-          <p:cNvSpPr/>
-          <p:nvPr/>
-        </p:nvSpPr>
-        <p:spPr>
-          <a:xfrm>
-            <a:off x="7772400" y="2180191"/>
-            <a:ext cx="3867912" cy="515983"/>
+          <p:cNvPr id="25" name="Shape 23"/>
+          <p:cNvSpPr/>
+          <p:nvPr/>
+        </p:nvSpPr>
+        <p:spPr>
+          <a:xfrm>
+            <a:off x="7772400" y="2261181"/>
+            <a:ext cx="3867912" cy="596973"/>
           </a:xfrm>
           <a:prstGeom prst="roundRect">
             <a:avLst>
-              <a:gd name="adj" fmla="val 10633"/>
+              <a:gd name="adj" fmla="val 9190"/>
             </a:avLst>
           </a:prstGeom>
           <a:solidFill>
@@ -8827,14 +8833,14 @@
       </p:sp>
       <p:sp>
         <p:nvSpPr>
-          <p:cNvPr id="25" name="Text 23"/>
-          <p:cNvSpPr/>
-          <p:nvPr/>
-        </p:nvSpPr>
-        <p:spPr>
-          <a:xfrm>
-            <a:off x="7845552" y="2180191"/>
-            <a:ext cx="329184" cy="515983"/>
+          <p:cNvPr id="26" name="Text 24"/>
+          <p:cNvSpPr/>
+          <p:nvPr/>
+        </p:nvSpPr>
+        <p:spPr>
+          <a:xfrm>
+            <a:off x="7845552" y="2261181"/>
+            <a:ext cx="329184" cy="596973"/>
           </a:xfrm>
           <a:prstGeom prst="rect">
             <a:avLst/>
@@ -8863,14 +8869,14 @@
       </p:sp>
       <p:sp>
         <p:nvSpPr>
-          <p:cNvPr id="26" name="Text 24"/>
-          <p:cNvSpPr/>
-          <p:nvPr/>
-        </p:nvSpPr>
-        <p:spPr>
-          <a:xfrm>
-            <a:off x="8266176" y="2198479"/>
-            <a:ext cx="3264408" cy="479407"/>
+          <p:cNvPr id="27" name="Text 25"/>
+          <p:cNvSpPr/>
+          <p:nvPr/>
+        </p:nvSpPr>
+        <p:spPr>
+          <a:xfrm>
+            <a:off x="8266176" y="2279469"/>
+            <a:ext cx="3264408" cy="560397"/>
           </a:xfrm>
           <a:prstGeom prst="rect">
             <a:avLst/>
@@ -8925,18 +8931,18 @@
       </p:sp>
       <p:sp>
         <p:nvSpPr>
-          <p:cNvPr id="27" name="Shape 25"/>
-          <p:cNvSpPr/>
-          <p:nvPr/>
-        </p:nvSpPr>
-        <p:spPr>
-          <a:xfrm>
-            <a:off x="7772400" y="2787614"/>
-            <a:ext cx="3867912" cy="515983"/>
+          <p:cNvPr id="28" name="Shape 26"/>
+          <p:cNvSpPr/>
+          <p:nvPr/>
+        </p:nvSpPr>
+        <p:spPr>
+          <a:xfrm>
+            <a:off x="7772400" y="2949593"/>
+            <a:ext cx="3867912" cy="596973"/>
           </a:xfrm>
           <a:prstGeom prst="roundRect">
             <a:avLst>
-              <a:gd name="adj" fmla="val 10633"/>
+              <a:gd name="adj" fmla="val 9190"/>
             </a:avLst>
           </a:prstGeom>
           <a:solidFill>
@@ -8947,14 +8953,14 @@
       </p:sp>
       <p:sp>
         <p:nvSpPr>
-          <p:cNvPr id="28" name="Text 26"/>
-          <p:cNvSpPr/>
-          <p:nvPr/>
-        </p:nvSpPr>
-        <p:spPr>
-          <a:xfrm>
-            <a:off x="7845552" y="2787614"/>
-            <a:ext cx="329184" cy="515983"/>
+          <p:cNvPr id="29" name="Text 27"/>
+          <p:cNvSpPr/>
+          <p:nvPr/>
+        </p:nvSpPr>
+        <p:spPr>
+          <a:xfrm>
+            <a:off x="7845552" y="2949593"/>
+            <a:ext cx="329184" cy="596973"/>
           </a:xfrm>
           <a:prstGeom prst="rect">
             <a:avLst/>
@@ -8983,14 +8989,14 @@
       </p:sp>
       <p:sp>
         <p:nvSpPr>
-          <p:cNvPr id="29" name="Text 27"/>
-          <p:cNvSpPr/>
-          <p:nvPr/>
-        </p:nvSpPr>
-        <p:spPr>
-          <a:xfrm>
-            <a:off x="8266176" y="2805902"/>
-            <a:ext cx="3264408" cy="479407"/>
+          <p:cNvPr id="30" name="Text 28"/>
+          <p:cNvSpPr/>
+          <p:nvPr/>
+        </p:nvSpPr>
+        <p:spPr>
+          <a:xfrm>
+            <a:off x="8266176" y="2967881"/>
+            <a:ext cx="3264408" cy="560397"/>
           </a:xfrm>
           <a:prstGeom prst="rect">
             <a:avLst/>
@@ -9045,18 +9051,18 @@
       </p:sp>
       <p:sp>
         <p:nvSpPr>
-          <p:cNvPr id="30" name="Shape 28"/>
-          <p:cNvSpPr/>
-          <p:nvPr/>
-        </p:nvSpPr>
-        <p:spPr>
-          <a:xfrm>
-            <a:off x="7772400" y="3395037"/>
-            <a:ext cx="3867912" cy="515983"/>
+          <p:cNvPr id="31" name="Shape 29"/>
+          <p:cNvSpPr/>
+          <p:nvPr/>
+        </p:nvSpPr>
+        <p:spPr>
+          <a:xfrm>
+            <a:off x="7772400" y="3638006"/>
+            <a:ext cx="3867912" cy="596973"/>
           </a:xfrm>
           <a:prstGeom prst="roundRect">
             <a:avLst>
-              <a:gd name="adj" fmla="val 10633"/>
+              <a:gd name="adj" fmla="val 9190"/>
             </a:avLst>
           </a:prstGeom>
           <a:solidFill>
@@ -9067,14 +9073,14 @@
       </p:sp>
       <p:sp>
         <p:nvSpPr>
-          <p:cNvPr id="31" name="Text 29"/>
-          <p:cNvSpPr/>
-          <p:nvPr/>
-        </p:nvSpPr>
-        <p:spPr>
-          <a:xfrm>
-            <a:off x="7845552" y="3395037"/>
-            <a:ext cx="329184" cy="515983"/>
+          <p:cNvPr id="32" name="Text 30"/>
+          <p:cNvSpPr/>
+          <p:nvPr/>
+        </p:nvSpPr>
+        <p:spPr>
+          <a:xfrm>
+            <a:off x="7845552" y="3638006"/>
+            <a:ext cx="329184" cy="596973"/>
           </a:xfrm>
           <a:prstGeom prst="rect">
             <a:avLst/>
@@ -9103,14 +9109,14 @@
       </p:sp>
       <p:sp>
         <p:nvSpPr>
-          <p:cNvPr id="32" name="Text 30"/>
-          <p:cNvSpPr/>
-          <p:nvPr/>
-        </p:nvSpPr>
-        <p:spPr>
-          <a:xfrm>
-            <a:off x="8266176" y="3413325"/>
-            <a:ext cx="3264408" cy="479407"/>
+          <p:cNvPr id="33" name="Text 31"/>
+          <p:cNvSpPr/>
+          <p:nvPr/>
+        </p:nvSpPr>
+        <p:spPr>
+          <a:xfrm>
+            <a:off x="8266176" y="3656294"/>
+            <a:ext cx="3264408" cy="560397"/>
           </a:xfrm>
           <a:prstGeom prst="rect">
             <a:avLst/>
@@ -9165,18 +9171,18 @@
       </p:sp>
       <p:sp>
         <p:nvSpPr>
-          <p:cNvPr id="33" name="Shape 31"/>
-          <p:cNvSpPr/>
-          <p:nvPr/>
-        </p:nvSpPr>
-        <p:spPr>
-          <a:xfrm>
-            <a:off x="7772400" y="4002459"/>
-            <a:ext cx="3867912" cy="515983"/>
+          <p:cNvPr id="34" name="Shape 32"/>
+          <p:cNvSpPr/>
+          <p:nvPr/>
+        </p:nvSpPr>
+        <p:spPr>
+          <a:xfrm>
+            <a:off x="7772400" y="4326418"/>
+            <a:ext cx="3867912" cy="596973"/>
           </a:xfrm>
           <a:prstGeom prst="roundRect">
             <a:avLst>
-              <a:gd name="adj" fmla="val 10633"/>
+              <a:gd name="adj" fmla="val 9190"/>
             </a:avLst>
           </a:prstGeom>
           <a:solidFill>
@@ -9187,14 +9193,14 @@
       </p:sp>
       <p:sp>
         <p:nvSpPr>
-          <p:cNvPr id="34" name="Text 32"/>
-          <p:cNvSpPr/>
-          <p:nvPr/>
-        </p:nvSpPr>
-        <p:spPr>
-          <a:xfrm>
-            <a:off x="7845552" y="4002459"/>
-            <a:ext cx="329184" cy="515983"/>
+          <p:cNvPr id="35" name="Text 33"/>
+          <p:cNvSpPr/>
+          <p:nvPr/>
+        </p:nvSpPr>
+        <p:spPr>
+          <a:xfrm>
+            <a:off x="7845552" y="4326418"/>
+            <a:ext cx="329184" cy="596973"/>
           </a:xfrm>
           <a:prstGeom prst="rect">
             <a:avLst/>
@@ -9223,14 +9229,14 @@
       </p:sp>
       <p:sp>
         <p:nvSpPr>
-          <p:cNvPr id="35" name="Text 33"/>
-          <p:cNvSpPr/>
-          <p:nvPr/>
-        </p:nvSpPr>
-        <p:spPr>
-          <a:xfrm>
-            <a:off x="8266176" y="4020747"/>
-            <a:ext cx="3264408" cy="479407"/>
+          <p:cNvPr id="36" name="Text 34"/>
+          <p:cNvSpPr/>
+          <p:nvPr/>
+        </p:nvSpPr>
+        <p:spPr>
+          <a:xfrm>
+            <a:off x="8266176" y="4344706"/>
+            <a:ext cx="3264408" cy="560397"/>
           </a:xfrm>
           <a:prstGeom prst="rect">
             <a:avLst/>
@@ -9285,18 +9291,18 @@
       </p:sp>
       <p:sp>
         <p:nvSpPr>
-          <p:cNvPr id="36" name="Shape 34"/>
-          <p:cNvSpPr/>
-          <p:nvPr/>
-        </p:nvSpPr>
-        <p:spPr>
-          <a:xfrm>
-            <a:off x="7772400" y="4609882"/>
-            <a:ext cx="3867912" cy="515983"/>
+          <p:cNvPr id="37" name="Shape 35"/>
+          <p:cNvSpPr/>
+          <p:nvPr/>
+        </p:nvSpPr>
+        <p:spPr>
+          <a:xfrm>
+            <a:off x="7772400" y="5014831"/>
+            <a:ext cx="3867912" cy="596973"/>
           </a:xfrm>
           <a:prstGeom prst="roundRect">
             <a:avLst>
-              <a:gd name="adj" fmla="val 10633"/>
+              <a:gd name="adj" fmla="val 9190"/>
             </a:avLst>
           </a:prstGeom>
           <a:solidFill>
@@ -9307,14 +9313,14 @@
       </p:sp>
       <p:sp>
         <p:nvSpPr>
-          <p:cNvPr id="37" name="Text 35"/>
-          <p:cNvSpPr/>
-          <p:nvPr/>
-        </p:nvSpPr>
-        <p:spPr>
-          <a:xfrm>
-            <a:off x="7845552" y="4609882"/>
-            <a:ext cx="329184" cy="515983"/>
+          <p:cNvPr id="38" name="Text 36"/>
+          <p:cNvSpPr/>
+          <p:nvPr/>
+        </p:nvSpPr>
+        <p:spPr>
+          <a:xfrm>
+            <a:off x="7845552" y="5014831"/>
+            <a:ext cx="329184" cy="596973"/>
           </a:xfrm>
           <a:prstGeom prst="rect">
             <a:avLst/>
@@ -9343,14 +9349,14 @@
       </p:sp>
       <p:sp>
         <p:nvSpPr>
-          <p:cNvPr id="38" name="Text 36"/>
-          <p:cNvSpPr/>
-          <p:nvPr/>
-        </p:nvSpPr>
-        <p:spPr>
-          <a:xfrm>
-            <a:off x="8266176" y="4628170"/>
-            <a:ext cx="3264408" cy="479407"/>
+          <p:cNvPr id="39" name="Text 37"/>
+          <p:cNvSpPr/>
+          <p:nvPr/>
+        </p:nvSpPr>
+        <p:spPr>
+          <a:xfrm>
+            <a:off x="8266176" y="5033119"/>
+            <a:ext cx="3264408" cy="560397"/>
           </a:xfrm>
           <a:prstGeom prst="rect">
             <a:avLst/>
@@ -9405,18 +9411,18 @@
       </p:sp>
       <p:sp>
         <p:nvSpPr>
-          <p:cNvPr id="39" name="Shape 37"/>
-          <p:cNvSpPr/>
-          <p:nvPr/>
-        </p:nvSpPr>
-        <p:spPr>
-          <a:xfrm>
-            <a:off x="7772400" y="5217305"/>
-            <a:ext cx="3867912" cy="515983"/>
+          <p:cNvPr id="40" name="Shape 38"/>
+          <p:cNvSpPr/>
+          <p:nvPr/>
+        </p:nvSpPr>
+        <p:spPr>
+          <a:xfrm>
+            <a:off x="7772400" y="5703243"/>
+            <a:ext cx="3867912" cy="596973"/>
           </a:xfrm>
           <a:prstGeom prst="roundRect">
             <a:avLst>
-              <a:gd name="adj" fmla="val 10633"/>
+              <a:gd name="adj" fmla="val 9190"/>
             </a:avLst>
           </a:prstGeom>
           <a:solidFill>
@@ -9427,14 +9433,14 @@
       </p:sp>
       <p:sp>
         <p:nvSpPr>
-          <p:cNvPr id="40" name="Text 38"/>
-          <p:cNvSpPr/>
-          <p:nvPr/>
-        </p:nvSpPr>
-        <p:spPr>
-          <a:xfrm>
-            <a:off x="7845552" y="5217305"/>
-            <a:ext cx="329184" cy="515983"/>
+          <p:cNvPr id="41" name="Text 39"/>
+          <p:cNvSpPr/>
+          <p:nvPr/>
+        </p:nvSpPr>
+        <p:spPr>
+          <a:xfrm>
+            <a:off x="7845552" y="5703243"/>
+            <a:ext cx="329184" cy="596973"/>
           </a:xfrm>
           <a:prstGeom prst="rect">
             <a:avLst/>
@@ -9463,14 +9469,14 @@
       </p:sp>
       <p:sp>
         <p:nvSpPr>
-          <p:cNvPr id="41" name="Text 39"/>
-          <p:cNvSpPr/>
-          <p:nvPr/>
-        </p:nvSpPr>
-        <p:spPr>
-          <a:xfrm>
-            <a:off x="8266176" y="5235593"/>
-            <a:ext cx="3264408" cy="479407"/>
+          <p:cNvPr id="42" name="Text 40"/>
+          <p:cNvSpPr/>
+          <p:nvPr/>
+        </p:nvSpPr>
+        <p:spPr>
+          <a:xfrm>
+            <a:off x="8266176" y="5721531"/>
+            <a:ext cx="3264408" cy="560397"/>
           </a:xfrm>
           <a:prstGeom prst="rect">
             <a:avLst/>
@@ -9525,7 +9531,7 @@
       </p:sp>
       <p:sp>
         <p:nvSpPr>
-          <p:cNvPr id="42" name="Text 40"/>
+          <p:cNvPr id="43" name="Text 41"/>
           <p:cNvSpPr/>
           <p:nvPr/>
         </p:nvSpPr>
@@ -9564,7 +9570,7 @@
       </p:sp>
       <p:sp>
         <p:nvSpPr>
-          <p:cNvPr id="43" name="Text 41"/>
+          <p:cNvPr id="44" name="Text 42"/>
           <p:cNvSpPr/>
           <p:nvPr/>
         </p:nvSpPr>
@@ -10057,80 +10063,18 @@
       </p:sp>
       <p:sp>
         <p:nvSpPr>
-          <p:cNvPr id="17" name="Text 15"/>
+          <p:cNvPr id="17" name="Shape 15"/>
           <p:cNvSpPr/>
           <p:nvPr/>
         </p:nvSpPr>
         <p:spPr>
           <a:xfrm>
             <a:off x="548640" y="4425696"/>
-            <a:ext cx="6949440" cy="457200"/>
-          </a:xfrm>
-          <a:prstGeom prst="rect">
-            <a:avLst/>
-          </a:prstGeom>
-          <a:noFill/>
-          <a:ln/>
-        </p:spPr>
-        <p:txBody>
-          <a:bodyPr wrap="square" lIns="0" tIns="0" rIns="0" bIns="0" rtlCol="0" anchor="ctr"/>
-          <a:lstStyle/>
-          <a:p>
-            <a:pPr algn="ctr" indent="0" marL="0">
-              <a:lnSpc>
-                <a:spcPct val="110000"/>
-              </a:lnSpc>
-              <a:buNone/>
-            </a:pPr>
-            <a:r>
-              <a:rPr lang="en-US" sz="1150" i="1" dirty="0">
-                <a:solidFill>
-                  <a:srgbClr val="5C6690"/>
-                </a:solidFill>
-                <a:latin typeface="Calibri" pitchFamily="34" charset="0"/>
-                <a:ea typeface="Calibri" pitchFamily="34" charset="-122"/>
-                <a:cs typeface="Calibri" pitchFamily="34" charset="-120"/>
-              </a:rPr>
-              <a:t>Museo interactivo inaugurado en 2000. Ocupa 40.000 m² en tres pisos,</a:t>
-            </a:r>
-            <a:endParaRPr lang="en-US" sz="1150" dirty="0"/>
-          </a:p>
-          <a:p>
-            <a:pPr algn="ctr" indent="0" marL="0">
-              <a:lnSpc>
-                <a:spcPct val="110000"/>
-              </a:lnSpc>
-              <a:buNone/>
-            </a:pPr>
-            <a:r>
-              <a:rPr lang="en-US" sz="1150" i="1" dirty="0">
-                <a:solidFill>
-                  <a:srgbClr val="5C6690"/>
-                </a:solidFill>
-                <a:latin typeface="Calibri" pitchFamily="34" charset="0"/>
-                <a:ea typeface="Calibri" pitchFamily="34" charset="-122"/>
-                <a:cs typeface="Calibri" pitchFamily="34" charset="-120"/>
-              </a:rPr>
-              <a:t>con una estructura de nervios que recuerda al esqueleto de un dinosaurio.</a:t>
-            </a:r>
-            <a:endParaRPr lang="en-US" sz="1150" dirty="0"/>
-          </a:p>
-        </p:txBody>
-      </p:sp>
-      <p:sp>
-        <p:nvSpPr>
-          <p:cNvPr id="18" name="Shape 16"/>
-          <p:cNvSpPr/>
-          <p:nvPr/>
-        </p:nvSpPr>
-        <p:spPr>
-          <a:xfrm>
-            <a:off x="7772400" y="1572768"/>
-            <a:ext cx="3867912" cy="576072"/>
+            <a:ext cx="6949440" cy="960120"/>
           </a:xfrm>
           <a:prstGeom prst="roundRect">
             <a:avLst>
-              <a:gd name="adj" fmla="val 9524"/>
+              <a:gd name="adj" fmla="val 7619"/>
             </a:avLst>
           </a:prstGeom>
           <a:solidFill>
@@ -10141,14 +10085,78 @@
       </p:sp>
       <p:sp>
         <p:nvSpPr>
-          <p:cNvPr id="19" name="Text 17"/>
+          <p:cNvPr id="18" name="Text 16"/>
+          <p:cNvSpPr/>
+          <p:nvPr/>
+        </p:nvSpPr>
+        <p:spPr>
+          <a:xfrm>
+            <a:off x="749808" y="4425696"/>
+            <a:ext cx="6547104" cy="960120"/>
+          </a:xfrm>
+          <a:prstGeom prst="rect">
+            <a:avLst/>
+          </a:prstGeom>
+          <a:noFill/>
+          <a:ln/>
+        </p:spPr>
+        <p:txBody>
+          <a:bodyPr wrap="square" lIns="0" tIns="0" rIns="0" bIns="0" rtlCol="0" anchor="ctr"/>
+          <a:lstStyle/>
+          <a:p>
+            <a:pPr algn="l" indent="0" marL="0">
+              <a:lnSpc>
+                <a:spcPct val="112000"/>
+              </a:lnSpc>
+              <a:buNone/>
+            </a:pPr>
+            <a:r>
+              <a:rPr lang="en-US" sz="1050" dirty="0">
+                <a:solidFill>
+                  <a:srgbClr val="2F3C7E"/>
+                </a:solidFill>
+                <a:latin typeface="Calibri" pitchFamily="34" charset="0"/>
+                <a:ea typeface="Calibri" pitchFamily="34" charset="-122"/>
+                <a:cs typeface="Calibri" pitchFamily="34" charset="-120"/>
+              </a:rPr>
+              <a:t>La arquitectura moderna (s. XX-XXI) rompió con los estilos históricos gracias a materiales como el acero y el hormigón, que permiten formas libres. Este museo, del arquitecto Santiago Calatrava, es un museo interactivo inaugurado en 2000, con una estructura de nervios que recuerda al esqueleto de un dinosaurio.</a:t>
+            </a:r>
+            <a:endParaRPr lang="en-US" sz="1050" dirty="0"/>
+          </a:p>
+        </p:txBody>
+      </p:sp>
+      <p:sp>
+        <p:nvSpPr>
+          <p:cNvPr id="19" name="Shape 17"/>
+          <p:cNvSpPr/>
+          <p:nvPr/>
+        </p:nvSpPr>
+        <p:spPr>
+          <a:xfrm>
+            <a:off x="7772400" y="1572768"/>
+            <a:ext cx="3867912" cy="689458"/>
+          </a:xfrm>
+          <a:prstGeom prst="roundRect">
+            <a:avLst>
+              <a:gd name="adj" fmla="val 7958"/>
+            </a:avLst>
+          </a:prstGeom>
+          <a:solidFill>
+            <a:srgbClr val="F5F6FB"/>
+          </a:solidFill>
+          <a:ln/>
+        </p:spPr>
+      </p:sp>
+      <p:sp>
+        <p:nvSpPr>
+          <p:cNvPr id="20" name="Text 18"/>
           <p:cNvSpPr/>
           <p:nvPr/>
         </p:nvSpPr>
         <p:spPr>
           <a:xfrm>
             <a:off x="7845552" y="1572768"/>
-            <a:ext cx="329184" cy="576072"/>
+            <a:ext cx="329184" cy="689458"/>
           </a:xfrm>
           <a:prstGeom prst="rect">
             <a:avLst/>
@@ -10177,14 +10185,14 @@
       </p:sp>
       <p:sp>
         <p:nvSpPr>
-          <p:cNvPr id="20" name="Text 18"/>
+          <p:cNvPr id="21" name="Text 19"/>
           <p:cNvSpPr/>
           <p:nvPr/>
         </p:nvSpPr>
         <p:spPr>
           <a:xfrm>
             <a:off x="8266176" y="1591056"/>
-            <a:ext cx="3264408" cy="539496"/>
+            <a:ext cx="3264408" cy="652882"/>
           </a:xfrm>
           <a:prstGeom prst="rect">
             <a:avLst/>
@@ -10239,18 +10247,18 @@
       </p:sp>
       <p:sp>
         <p:nvSpPr>
-          <p:cNvPr id="21" name="Shape 19"/>
-          <p:cNvSpPr/>
-          <p:nvPr/>
-        </p:nvSpPr>
-        <p:spPr>
-          <a:xfrm>
-            <a:off x="7772400" y="2240280"/>
-            <a:ext cx="3867912" cy="576072"/>
+          <p:cNvPr id="22" name="Shape 20"/>
+          <p:cNvSpPr/>
+          <p:nvPr/>
+        </p:nvSpPr>
+        <p:spPr>
+          <a:xfrm>
+            <a:off x="7772400" y="2353666"/>
+            <a:ext cx="3867912" cy="689458"/>
           </a:xfrm>
           <a:prstGeom prst="roundRect">
             <a:avLst>
-              <a:gd name="adj" fmla="val 9524"/>
+              <a:gd name="adj" fmla="val 7958"/>
             </a:avLst>
           </a:prstGeom>
           <a:solidFill>
@@ -10261,14 +10269,14 @@
       </p:sp>
       <p:sp>
         <p:nvSpPr>
-          <p:cNvPr id="22" name="Text 20"/>
-          <p:cNvSpPr/>
-          <p:nvPr/>
-        </p:nvSpPr>
-        <p:spPr>
-          <a:xfrm>
-            <a:off x="7845552" y="2240280"/>
-            <a:ext cx="329184" cy="576072"/>
+          <p:cNvPr id="23" name="Text 21"/>
+          <p:cNvSpPr/>
+          <p:nvPr/>
+        </p:nvSpPr>
+        <p:spPr>
+          <a:xfrm>
+            <a:off x="7845552" y="2353666"/>
+            <a:ext cx="329184" cy="689458"/>
           </a:xfrm>
           <a:prstGeom prst="rect">
             <a:avLst/>
@@ -10297,14 +10305,14 @@
       </p:sp>
       <p:sp>
         <p:nvSpPr>
-          <p:cNvPr id="23" name="Text 21"/>
-          <p:cNvSpPr/>
-          <p:nvPr/>
-        </p:nvSpPr>
-        <p:spPr>
-          <a:xfrm>
-            <a:off x="8266176" y="2258568"/>
-            <a:ext cx="3264408" cy="539496"/>
+          <p:cNvPr id="24" name="Text 22"/>
+          <p:cNvSpPr/>
+          <p:nvPr/>
+        </p:nvSpPr>
+        <p:spPr>
+          <a:xfrm>
+            <a:off x="8266176" y="2371954"/>
+            <a:ext cx="3264408" cy="652882"/>
           </a:xfrm>
           <a:prstGeom prst="rect">
             <a:avLst/>
@@ -10359,18 +10367,18 @@
       </p:sp>
       <p:sp>
         <p:nvSpPr>
-          <p:cNvPr id="24" name="Shape 22"/>
-          <p:cNvSpPr/>
-          <p:nvPr/>
-        </p:nvSpPr>
-        <p:spPr>
-          <a:xfrm>
-            <a:off x="7772400" y="2907792"/>
-            <a:ext cx="3867912" cy="576072"/>
+          <p:cNvPr id="25" name="Shape 23"/>
+          <p:cNvSpPr/>
+          <p:nvPr/>
+        </p:nvSpPr>
+        <p:spPr>
+          <a:xfrm>
+            <a:off x="7772400" y="3134563"/>
+            <a:ext cx="3867912" cy="689458"/>
           </a:xfrm>
           <a:prstGeom prst="roundRect">
             <a:avLst>
-              <a:gd name="adj" fmla="val 9524"/>
+              <a:gd name="adj" fmla="val 7958"/>
             </a:avLst>
           </a:prstGeom>
           <a:solidFill>
@@ -10381,14 +10389,14 @@
       </p:sp>
       <p:sp>
         <p:nvSpPr>
-          <p:cNvPr id="25" name="Text 23"/>
-          <p:cNvSpPr/>
-          <p:nvPr/>
-        </p:nvSpPr>
-        <p:spPr>
-          <a:xfrm>
-            <a:off x="7845552" y="2907792"/>
-            <a:ext cx="329184" cy="576072"/>
+          <p:cNvPr id="26" name="Text 24"/>
+          <p:cNvSpPr/>
+          <p:nvPr/>
+        </p:nvSpPr>
+        <p:spPr>
+          <a:xfrm>
+            <a:off x="7845552" y="3134563"/>
+            <a:ext cx="329184" cy="689458"/>
           </a:xfrm>
           <a:prstGeom prst="rect">
             <a:avLst/>
@@ -10417,14 +10425,14 @@
       </p:sp>
       <p:sp>
         <p:nvSpPr>
-          <p:cNvPr id="26" name="Text 24"/>
-          <p:cNvSpPr/>
-          <p:nvPr/>
-        </p:nvSpPr>
-        <p:spPr>
-          <a:xfrm>
-            <a:off x="8266176" y="2926080"/>
-            <a:ext cx="3264408" cy="539496"/>
+          <p:cNvPr id="27" name="Text 25"/>
+          <p:cNvSpPr/>
+          <p:nvPr/>
+        </p:nvSpPr>
+        <p:spPr>
+          <a:xfrm>
+            <a:off x="8266176" y="3152851"/>
+            <a:ext cx="3264408" cy="652882"/>
           </a:xfrm>
           <a:prstGeom prst="rect">
             <a:avLst/>
@@ -10479,18 +10487,18 @@
       </p:sp>
       <p:sp>
         <p:nvSpPr>
-          <p:cNvPr id="27" name="Shape 25"/>
-          <p:cNvSpPr/>
-          <p:nvPr/>
-        </p:nvSpPr>
-        <p:spPr>
-          <a:xfrm>
-            <a:off x="7772400" y="3575304"/>
-            <a:ext cx="3867912" cy="576072"/>
+          <p:cNvPr id="28" name="Shape 26"/>
+          <p:cNvSpPr/>
+          <p:nvPr/>
+        </p:nvSpPr>
+        <p:spPr>
+          <a:xfrm>
+            <a:off x="7772400" y="3915461"/>
+            <a:ext cx="3867912" cy="689458"/>
           </a:xfrm>
           <a:prstGeom prst="roundRect">
             <a:avLst>
-              <a:gd name="adj" fmla="val 9524"/>
+              <a:gd name="adj" fmla="val 7958"/>
             </a:avLst>
           </a:prstGeom>
           <a:solidFill>
@@ -10501,14 +10509,14 @@
       </p:sp>
       <p:sp>
         <p:nvSpPr>
-          <p:cNvPr id="28" name="Text 26"/>
-          <p:cNvSpPr/>
-          <p:nvPr/>
-        </p:nvSpPr>
-        <p:spPr>
-          <a:xfrm>
-            <a:off x="7845552" y="3575304"/>
-            <a:ext cx="329184" cy="576072"/>
+          <p:cNvPr id="29" name="Text 27"/>
+          <p:cNvSpPr/>
+          <p:nvPr/>
+        </p:nvSpPr>
+        <p:spPr>
+          <a:xfrm>
+            <a:off x="7845552" y="3915461"/>
+            <a:ext cx="329184" cy="689458"/>
           </a:xfrm>
           <a:prstGeom prst="rect">
             <a:avLst/>
@@ -10537,14 +10545,14 @@
       </p:sp>
       <p:sp>
         <p:nvSpPr>
-          <p:cNvPr id="29" name="Text 27"/>
-          <p:cNvSpPr/>
-          <p:nvPr/>
-        </p:nvSpPr>
-        <p:spPr>
-          <a:xfrm>
-            <a:off x="8266176" y="3593592"/>
-            <a:ext cx="3264408" cy="539496"/>
+          <p:cNvPr id="30" name="Text 28"/>
+          <p:cNvSpPr/>
+          <p:nvPr/>
+        </p:nvSpPr>
+        <p:spPr>
+          <a:xfrm>
+            <a:off x="8266176" y="3933749"/>
+            <a:ext cx="3264408" cy="652882"/>
           </a:xfrm>
           <a:prstGeom prst="rect">
             <a:avLst/>
@@ -10599,18 +10607,18 @@
       </p:sp>
       <p:sp>
         <p:nvSpPr>
-          <p:cNvPr id="30" name="Shape 28"/>
-          <p:cNvSpPr/>
-          <p:nvPr/>
-        </p:nvSpPr>
-        <p:spPr>
-          <a:xfrm>
-            <a:off x="7772400" y="4242816"/>
-            <a:ext cx="3867912" cy="576072"/>
+          <p:cNvPr id="31" name="Shape 29"/>
+          <p:cNvSpPr/>
+          <p:nvPr/>
+        </p:nvSpPr>
+        <p:spPr>
+          <a:xfrm>
+            <a:off x="7772400" y="4696358"/>
+            <a:ext cx="3867912" cy="689458"/>
           </a:xfrm>
           <a:prstGeom prst="roundRect">
             <a:avLst>
-              <a:gd name="adj" fmla="val 9524"/>
+              <a:gd name="adj" fmla="val 7958"/>
             </a:avLst>
           </a:prstGeom>
           <a:solidFill>
@@ -10621,14 +10629,14 @@
       </p:sp>
       <p:sp>
         <p:nvSpPr>
-          <p:cNvPr id="31" name="Text 29"/>
-          <p:cNvSpPr/>
-          <p:nvPr/>
-        </p:nvSpPr>
-        <p:spPr>
-          <a:xfrm>
-            <a:off x="7845552" y="4242816"/>
-            <a:ext cx="329184" cy="576072"/>
+          <p:cNvPr id="32" name="Text 30"/>
+          <p:cNvSpPr/>
+          <p:nvPr/>
+        </p:nvSpPr>
+        <p:spPr>
+          <a:xfrm>
+            <a:off x="7845552" y="4696358"/>
+            <a:ext cx="329184" cy="689458"/>
           </a:xfrm>
           <a:prstGeom prst="rect">
             <a:avLst/>
@@ -10657,14 +10665,14 @@
       </p:sp>
       <p:sp>
         <p:nvSpPr>
-          <p:cNvPr id="32" name="Text 30"/>
-          <p:cNvSpPr/>
-          <p:nvPr/>
-        </p:nvSpPr>
-        <p:spPr>
-          <a:xfrm>
-            <a:off x="8266176" y="4261104"/>
-            <a:ext cx="3264408" cy="539496"/>
+          <p:cNvPr id="33" name="Text 31"/>
+          <p:cNvSpPr/>
+          <p:nvPr/>
+        </p:nvSpPr>
+        <p:spPr>
+          <a:xfrm>
+            <a:off x="8266176" y="4714646"/>
+            <a:ext cx="3264408" cy="652882"/>
           </a:xfrm>
           <a:prstGeom prst="rect">
             <a:avLst/>
@@ -10719,7 +10727,7 @@
       </p:sp>
       <p:sp>
         <p:nvSpPr>
-          <p:cNvPr id="33" name="Text 31"/>
+          <p:cNvPr id="34" name="Text 32"/>
           <p:cNvSpPr/>
           <p:nvPr/>
         </p:nvSpPr>
@@ -10758,7 +10766,7 @@
       </p:sp>
       <p:sp>
         <p:nvSpPr>
-          <p:cNvPr id="34" name="Text 32"/>
+          <p:cNvPr id="35" name="Text 33"/>
           <p:cNvSpPr/>
           <p:nvPr/>
         </p:nvSpPr>

</xml_diff>

<commit_message>
Quita la firma final de las presentaciones y ajusta iconos de portada
Incorpora las correcciones del profesor: elimina la línea de firma
"— Angel Luis Acosta González, tu profesor de español" de la
diapositiva de cierre, y deja 4 iconos en la portada (uno por estilo)
en vez de 5. Añade regla en CLAUDE.md para no volver a añadir esa
firma en presentaciones futuras.

Co-Authored-By: Claude Sonnet 5 <noreply@anthropic.com>
Claude-Session: https://claude.ai/code/session_01SV4AB4NNKiXaeMuGEkh2i2
</commit_message>
<xml_diff>
--- a/docencia-espanol/materiales/b2/nuevo-espanol-en-marcha-4_unidad12b_lexico-arte.pptx
+++ b/docencia-espanol/materiales/b2/nuevo-espanol-en-marcha-4_unidad12b_lexico-arte.pptx
@@ -2106,7 +2106,7 @@
                   <a:srgbClr val="000000"/>
                 </a:solidFill>
               </a:rPr>
-              <a:t>🔬</a:t>
+              <a:t>📐</a:t>
             </a:r>
             <a:endParaRPr lang="en-US" sz="3000" dirty="0"/>
           </a:p>
@@ -2114,70 +2114,7 @@
       </p:sp>
       <p:sp>
         <p:nvSpPr>
-          <p:cNvPr id="15" name="Shape 13"/>
-          <p:cNvSpPr/>
-          <p:nvPr/>
-        </p:nvSpPr>
-        <p:spPr>
-          <a:xfrm>
-            <a:off x="4663440" y="5074920"/>
-            <a:ext cx="777240" cy="777240"/>
-          </a:xfrm>
-          <a:prstGeom prst="ellipse">
-            <a:avLst/>
-          </a:prstGeom>
-          <a:solidFill>
-            <a:srgbClr val="F96167"/>
-          </a:solidFill>
-          <a:ln/>
-          <a:effectLst>
-            <a:outerShdw sx="100000" sy="100000" kx="0" ky="0" algn="bl" rotWithShape="0" blurRad="76200" dist="38100" dir="5400000">
-              <a:srgbClr val="1B2340">
-                <a:alpha val="18000"/>
-              </a:srgbClr>
-            </a:outerShdw>
-          </a:effectLst>
-        </p:spPr>
-      </p:sp>
-      <p:sp>
-        <p:nvSpPr>
-          <p:cNvPr id="16" name="Text 14"/>
-          <p:cNvSpPr/>
-          <p:nvPr/>
-        </p:nvSpPr>
-        <p:spPr>
-          <a:xfrm>
-            <a:off x="4663440" y="5074920"/>
-            <a:ext cx="777240" cy="777240"/>
-          </a:xfrm>
-          <a:prstGeom prst="rect">
-            <a:avLst/>
-          </a:prstGeom>
-          <a:noFill/>
-          <a:ln/>
-        </p:spPr>
-        <p:txBody>
-          <a:bodyPr wrap="square" lIns="0" tIns="0" rIns="0" bIns="0" rtlCol="0" anchor="ctr"/>
-          <a:lstStyle/>
-          <a:p>
-            <a:pPr algn="ctr" indent="0" marL="0">
-              <a:buNone/>
-            </a:pPr>
-            <a:r>
-              <a:rPr lang="en-US" sz="3000" dirty="0">
-                <a:solidFill>
-                  <a:srgbClr val="000000"/>
-                </a:solidFill>
-              </a:rPr>
-              <a:t>📐</a:t>
-            </a:r>
-            <a:endParaRPr lang="en-US" sz="3000" dirty="0"/>
-          </a:p>
-        </p:txBody>
-      </p:sp>
-      <p:sp>
-        <p:nvSpPr>
-          <p:cNvPr id="17" name="Text 15"/>
+          <p:cNvPr id="15" name="Text 13"/>
           <p:cNvSpPr/>
           <p:nvPr/>
         </p:nvSpPr>
@@ -2216,7 +2153,7 @@
       </p:sp>
       <p:sp>
         <p:nvSpPr>
-          <p:cNvPr id="18" name="Text 16"/>
+          <p:cNvPr id="16" name="Text 14"/>
           <p:cNvSpPr/>
           <p:nvPr/>
         </p:nvSpPr>
@@ -2521,45 +2458,6 @@
       <p:sp>
         <p:nvSpPr>
           <p:cNvPr id="7" name="Text 5"/>
-          <p:cNvSpPr/>
-          <p:nvPr/>
-        </p:nvSpPr>
-        <p:spPr>
-          <a:xfrm>
-            <a:off x="822960" y="5074920"/>
-            <a:ext cx="9784080" cy="365760"/>
-          </a:xfrm>
-          <a:prstGeom prst="rect">
-            <a:avLst/>
-          </a:prstGeom>
-          <a:noFill/>
-          <a:ln/>
-        </p:spPr>
-        <p:txBody>
-          <a:bodyPr wrap="square" lIns="0" tIns="0" rIns="0" bIns="0" rtlCol="0" anchor="ctr"/>
-          <a:lstStyle/>
-          <a:p>
-            <a:pPr indent="0" marL="0">
-              <a:buNone/>
-            </a:pPr>
-            <a:r>
-              <a:rPr lang="en-US" sz="1500" i="1" dirty="0">
-                <a:solidFill>
-                  <a:srgbClr val="F9E795"/>
-                </a:solidFill>
-                <a:latin typeface="Cambria" pitchFamily="34" charset="0"/>
-                <a:ea typeface="Cambria" pitchFamily="34" charset="-122"/>
-                <a:cs typeface="Cambria" pitchFamily="34" charset="-120"/>
-              </a:rPr>
-              <a:t>— Angel Luis Acosta González, tu profesor de español</a:t>
-            </a:r>
-            <a:endParaRPr lang="en-US" sz="1500" dirty="0"/>
-          </a:p>
-        </p:txBody>
-      </p:sp>
-      <p:sp>
-        <p:nvSpPr>
-          <p:cNvPr id="8" name="Text 6"/>
           <p:cNvSpPr/>
           <p:nvPr/>
         </p:nvSpPr>

</xml_diff>